<commit_message>
docs: add live Render deployment link and update presentation
</commit_message>
<xml_diff>
--- a/FortressFi_Winning_Presentation.pptx
+++ b/FortressFi_Winning_Presentation.pptx
@@ -3742,6 +3742,80 @@
           </a:p>
         </p:txBody>
       </p:sp>
+      <p:sp>
+        <p:nvSpPr>
+          <p:cNvPr id="26" name="Rounded Rectangle 25"/>
+          <p:cNvSpPr/>
+          <p:nvPr/>
+        </p:nvSpPr>
+        <p:spPr>
+          <a:xfrm>
+            <a:off x="1463040" y="8412480"/>
+            <a:ext cx="15910559" cy="1280160"/>
+          </a:xfrm>
+          <a:prstGeom prst="roundRect">
+            <a:avLst/>
+          </a:prstGeom>
+          <a:solidFill>
+            <a:srgbClr val="0F172A"/>
+          </a:solidFill>
+          <a:ln w="19050">
+            <a:solidFill>
+              <a:srgbClr val="10B981"/>
+            </a:solidFill>
+          </a:ln>
+        </p:spPr>
+        <p:style>
+          <a:lnRef idx="1">
+            <a:schemeClr val="accent1"/>
+          </a:lnRef>
+          <a:fillRef idx="3">
+            <a:schemeClr val="accent1"/>
+          </a:fillRef>
+          <a:effectRef idx="2">
+            <a:schemeClr val="accent1"/>
+          </a:effectRef>
+          <a:fontRef idx="minor">
+            <a:schemeClr val="lt1"/>
+          </a:fontRef>
+        </p:style>
+        <p:txBody>
+          <a:bodyPr rtlCol="0" anchor="ctr" wrap="square" lIns="228600" rIns="228600" tIns="228600" bIns="228600"/>
+          <a:lstStyle/>
+          <a:p>
+            <a:pPr algn="ctr">
+              <a:spcAft>
+                <a:spcPts val="300"/>
+              </a:spcAft>
+              <a:defRPr sz="1600" b="1">
+                <a:solidFill>
+                  <a:srgbClr val="34D399"/>
+                </a:solidFill>
+                <a:latin typeface="Arial"/>
+              </a:defRPr>
+            </a:pPr>
+            <a:r>
+              <a:t>INIT'26 FINTECH HACKATHON // ASSET &amp; CAPITAL MANAGEMENT TRACK</a:t>
+            </a:r>
+          </a:p>
+          <a:p>
+            <a:pPr algn="ctr">
+              <a:spcAft>
+                <a:spcPts val="0"/>
+              </a:spcAft>
+              <a:defRPr sz="2000" b="1">
+                <a:solidFill>
+                  <a:srgbClr val="FFFFFF"/>
+                </a:solidFill>
+                <a:latin typeface="Arial"/>
+              </a:defRPr>
+            </a:pPr>
+            <a:r>
+              <a:t>FortressFi : Autonomous Institutional Risk-Guardrail Portfolio Engine</a:t>
+            </a:r>
+          </a:p>
+        </p:txBody>
+      </p:sp>
     </p:spTree>
   </p:cSld>
   <p:clrMapOvr>
@@ -4038,6 +4112,112 @@
       <p:sp>
         <p:nvSpPr>
           <p:cNvPr id="7" name="Rounded Rectangle 6"/>
+          <p:cNvSpPr/>
+          <p:nvPr/>
+        </p:nvSpPr>
+        <p:spPr>
+          <a:xfrm>
+            <a:off x="1463040" y="6217920"/>
+            <a:ext cx="15910559" cy="3291840"/>
+          </a:xfrm>
+          <a:prstGeom prst="roundRect">
+            <a:avLst/>
+          </a:prstGeom>
+          <a:solidFill>
+            <a:srgbClr val="0F172A"/>
+          </a:solidFill>
+          <a:ln w="19050">
+            <a:solidFill>
+              <a:srgbClr val="10B981"/>
+            </a:solidFill>
+          </a:ln>
+        </p:spPr>
+        <p:style>
+          <a:lnRef idx="1">
+            <a:schemeClr val="accent1"/>
+          </a:lnRef>
+          <a:fillRef idx="3">
+            <a:schemeClr val="accent1"/>
+          </a:fillRef>
+          <a:effectRef idx="2">
+            <a:schemeClr val="accent1"/>
+          </a:effectRef>
+          <a:fontRef idx="minor">
+            <a:schemeClr val="lt1"/>
+          </a:fontRef>
+        </p:style>
+        <p:txBody>
+          <a:bodyPr rtlCol="0" anchor="ctr" wrap="square" lIns="228600" rIns="228600" tIns="228600" bIns="228600"/>
+          <a:lstStyle/>
+          <a:p>
+            <a:pPr algn="ctr">
+              <a:spcAft>
+                <a:spcPts val="1000"/>
+              </a:spcAft>
+              <a:defRPr sz="2000" b="1">
+                <a:solidFill>
+                  <a:srgbClr val="34D399"/>
+                </a:solidFill>
+                <a:latin typeface="Arial"/>
+              </a:defRPr>
+            </a:pPr>
+            <a:r>
+              <a:t>[CORE IDEA] The Simple Human Intuition Behind FortressFi : 'Cruise Control for Capital'</a:t>
+            </a:r>
+          </a:p>
+          <a:p>
+            <a:pPr>
+              <a:spcAft>
+                <a:spcPts val="600"/>
+              </a:spcAft>
+              <a:defRPr sz="1700" b="0">
+                <a:solidFill>
+                  <a:srgbClr val="FFFFFF"/>
+                </a:solidFill>
+                <a:latin typeface="Arial"/>
+              </a:defRPr>
+            </a:pPr>
+            <a:r>
+              <a:t>• Driving a car on a highway: You want cruise control to smoothly maintain your speed and save fuel.</a:t>
+            </a:r>
+          </a:p>
+          <a:p>
+            <a:pPr>
+              <a:spcAft>
+                <a:spcPts val="600"/>
+              </a:spcAft>
+              <a:defRPr sz="1700" b="0">
+                <a:solidFill>
+                  <a:srgbClr val="FFFFFF"/>
+                </a:solidFill>
+                <a:latin typeface="Arial"/>
+              </a:defRPr>
+            </a:pPr>
+            <a:r>
+              <a:t>• Sudden obstacle on the road: You need automatic emergency braking before you even realize you're in danger.</a:t>
+            </a:r>
+          </a:p>
+          <a:p>
+            <a:pPr>
+              <a:spcAft>
+                <a:spcPts val="0"/>
+              </a:spcAft>
+              <a:defRPr sz="1700" b="0">
+                <a:solidFill>
+                  <a:srgbClr val="CBD5E1"/>
+                </a:solidFill>
+                <a:latin typeface="Arial"/>
+              </a:defRPr>
+            </a:pPr>
+            <a:r>
+              <a:t>• FortressFi brings that exact balance to investment portfolios: it quietly maximizes returns when markets are steady, but the second risk metrics spike, it automatically taps the brakes and shields capital into safe cash and government bonds.</a:t>
+            </a:r>
+          </a:p>
+        </p:txBody>
+      </p:sp>
+      <p:sp>
+        <p:nvSpPr>
+          <p:cNvPr id="8" name="Rounded Rectangle 7"/>
           <p:cNvSpPr/>
           <p:nvPr/>
         </p:nvSpPr>
@@ -5291,6 +5471,548 @@
           </a:p>
         </p:txBody>
       </p:sp>
+      <p:sp>
+        <p:nvSpPr>
+          <p:cNvPr id="11" name="Rounded Rectangle 10"/>
+          <p:cNvSpPr/>
+          <p:nvPr/>
+        </p:nvSpPr>
+        <p:spPr>
+          <a:xfrm>
+            <a:off x="1463040" y="1920240"/>
+            <a:ext cx="5029200" cy="7680960"/>
+          </a:xfrm>
+          <a:prstGeom prst="roundRect">
+            <a:avLst/>
+          </a:prstGeom>
+          <a:solidFill>
+            <a:srgbClr val="0F172A"/>
+          </a:solidFill>
+          <a:ln w="19050">
+            <a:solidFill>
+              <a:srgbClr val="EF4444"/>
+            </a:solidFill>
+          </a:ln>
+        </p:spPr>
+        <p:style>
+          <a:lnRef idx="1">
+            <a:schemeClr val="accent1"/>
+          </a:lnRef>
+          <a:fillRef idx="3">
+            <a:schemeClr val="accent1"/>
+          </a:fillRef>
+          <a:effectRef idx="2">
+            <a:schemeClr val="accent1"/>
+          </a:effectRef>
+          <a:fontRef idx="minor">
+            <a:schemeClr val="lt1"/>
+          </a:fontRef>
+        </p:style>
+        <p:txBody>
+          <a:bodyPr rtlCol="0" anchor="ctr" wrap="square" lIns="228600" rIns="228600" tIns="228600" bIns="228600"/>
+          <a:lstStyle/>
+          <a:p>
+            <a:pPr algn="ctr">
+              <a:spcAft>
+                <a:spcPts val="1000"/>
+              </a:spcAft>
+              <a:defRPr sz="1800" b="1">
+                <a:solidFill>
+                  <a:srgbClr val="F87171"/>
+                </a:solidFill>
+                <a:latin typeface="Arial"/>
+              </a:defRPr>
+            </a:pPr>
+            <a:r>
+              <a:t>1. THE PROBLEM WE OBSERVED</a:t>
+            </a:r>
+          </a:p>
+          <a:p>
+            <a:pPr>
+              <a:spcAft>
+                <a:spcPts val="1200"/>
+              </a:spcAft>
+              <a:defRPr sz="1400" b="0">
+                <a:solidFill>
+                  <a:srgbClr val="94A3B8"/>
+                </a:solidFill>
+                <a:latin typeface="Arial"/>
+              </a:defRPr>
+            </a:pPr>
+            <a:r>
+              <a:t>Why existing systems fail real investors:</a:t>
+            </a:r>
+          </a:p>
+          <a:p>
+            <a:pPr>
+              <a:spcAft>
+                <a:spcPts val="300"/>
+              </a:spcAft>
+              <a:defRPr sz="1600" b="1">
+                <a:solidFill>
+                  <a:srgbClr val="FFFFFF"/>
+                </a:solidFill>
+                <a:latin typeface="Arial"/>
+              </a:defRPr>
+            </a:pPr>
+            <a:r>
+              <a:t>• Manual Rebalancing is Too Slow:</a:t>
+            </a:r>
+          </a:p>
+          <a:p>
+            <a:pPr>
+              <a:spcAft>
+                <a:spcPts val="1000"/>
+              </a:spcAft>
+              <a:defRPr sz="1400" b="0">
+                <a:solidFill>
+                  <a:srgbClr val="CBD5E1"/>
+                </a:solidFill>
+                <a:latin typeface="Arial"/>
+              </a:defRPr>
+            </a:pPr>
+            <a:r>
+              <a:t>Monthly reviews or investment committees take days. In a flash crash, losses happen in minutes.</a:t>
+            </a:r>
+          </a:p>
+          <a:p>
+            <a:pPr>
+              <a:spcAft>
+                <a:spcPts val="300"/>
+              </a:spcAft>
+              <a:defRPr sz="1600" b="1">
+                <a:solidFill>
+                  <a:srgbClr val="FFFFFF"/>
+                </a:solidFill>
+                <a:latin typeface="Arial"/>
+              </a:defRPr>
+            </a:pPr>
+            <a:r>
+              <a:t>• High-Frequency Trading Destroys Profits:</a:t>
+            </a:r>
+          </a:p>
+          <a:p>
+            <a:pPr>
+              <a:spcAft>
+                <a:spcPts val="1000"/>
+              </a:spcAft>
+              <a:defRPr sz="1400" b="0">
+                <a:solidFill>
+                  <a:srgbClr val="CBD5E1"/>
+                </a:solidFill>
+                <a:latin typeface="Arial"/>
+              </a:defRPr>
+            </a:pPr>
+            <a:r>
+              <a:t>Constantly trading on every small price tick racks up massive broker fees, turnover drag, and bid-ask slippage.</a:t>
+            </a:r>
+          </a:p>
+          <a:p>
+            <a:pPr>
+              <a:spcAft>
+                <a:spcPts val="300"/>
+              </a:spcAft>
+              <a:defRPr sz="1600" b="1">
+                <a:solidFill>
+                  <a:srgbClr val="FFFFFF"/>
+                </a:solidFill>
+                <a:latin typeface="Arial"/>
+              </a:defRPr>
+            </a:pPr>
+            <a:r>
+              <a:t>• Black-Box AI Lacks Trust:</a:t>
+            </a:r>
+          </a:p>
+          <a:p>
+            <a:pPr>
+              <a:spcAft>
+                <a:spcPts val="0"/>
+              </a:spcAft>
+              <a:defRPr sz="1400" b="0">
+                <a:solidFill>
+                  <a:srgbClr val="CBD5E1"/>
+                </a:solidFill>
+                <a:latin typeface="Arial"/>
+              </a:defRPr>
+            </a:pPr>
+            <a:r>
+              <a:t>Complex neural nets move millions without explaining 'why'. When panic hits, managers just turn them off.</a:t>
+            </a:r>
+          </a:p>
+        </p:txBody>
+      </p:sp>
+      <p:sp>
+        <p:nvSpPr>
+          <p:cNvPr id="12" name="Rounded Rectangle 11"/>
+          <p:cNvSpPr/>
+          <p:nvPr/>
+        </p:nvSpPr>
+        <p:spPr>
+          <a:xfrm>
+            <a:off x="6903720" y="1920240"/>
+            <a:ext cx="5029200" cy="7680960"/>
+          </a:xfrm>
+          <a:prstGeom prst="roundRect">
+            <a:avLst/>
+          </a:prstGeom>
+          <a:solidFill>
+            <a:srgbClr val="0F172A"/>
+          </a:solidFill>
+          <a:ln w="19050">
+            <a:solidFill>
+              <a:srgbClr val="0EA5E9"/>
+            </a:solidFill>
+          </a:ln>
+        </p:spPr>
+        <p:style>
+          <a:lnRef idx="1">
+            <a:schemeClr val="accent1"/>
+          </a:lnRef>
+          <a:fillRef idx="3">
+            <a:schemeClr val="accent1"/>
+          </a:fillRef>
+          <a:effectRef idx="2">
+            <a:schemeClr val="accent1"/>
+          </a:effectRef>
+          <a:fontRef idx="minor">
+            <a:schemeClr val="lt1"/>
+          </a:fontRef>
+        </p:style>
+        <p:txBody>
+          <a:bodyPr rtlCol="0" anchor="ctr" wrap="square" lIns="228600" rIns="228600" tIns="228600" bIns="228600"/>
+          <a:lstStyle/>
+          <a:p>
+            <a:pPr algn="ctr">
+              <a:spcAft>
+                <a:spcPts val="1000"/>
+              </a:spcAft>
+              <a:defRPr sz="1800" b="1">
+                <a:solidFill>
+                  <a:srgbClr val="38BDF8"/>
+                </a:solidFill>
+                <a:latin typeface="Arial"/>
+              </a:defRPr>
+            </a:pPr>
+            <a:r>
+              <a:t>2. OUR SOLUTION: DECOUPLED DUAL ENGINE</a:t>
+            </a:r>
+          </a:p>
+          <a:p>
+            <a:pPr>
+              <a:spcAft>
+                <a:spcPts val="1200"/>
+              </a:spcAft>
+              <a:defRPr sz="1400" b="0">
+                <a:solidFill>
+                  <a:srgbClr val="94A3B8"/>
+                </a:solidFill>
+                <a:latin typeface="Arial"/>
+              </a:defRPr>
+            </a:pPr>
+            <a:r>
+              <a:t>Separating profit optimization from risk defense:</a:t>
+            </a:r>
+          </a:p>
+          <a:p>
+            <a:pPr>
+              <a:spcAft>
+                <a:spcPts val="300"/>
+              </a:spcAft>
+              <a:defRPr sz="1600" b="1">
+                <a:solidFill>
+                  <a:srgbClr val="FFFFFF"/>
+                </a:solidFill>
+                <a:latin typeface="Arial"/>
+              </a:defRPr>
+            </a:pPr>
+            <a:r>
+              <a:t>• Engine 1: The Accelerator (Optimizer)</a:t>
+            </a:r>
+          </a:p>
+          <a:p>
+            <a:pPr>
+              <a:spcAft>
+                <a:spcPts val="1000"/>
+              </a:spcAft>
+              <a:defRPr sz="1400" b="0">
+                <a:solidFill>
+                  <a:srgbClr val="CBD5E1"/>
+                </a:solidFill>
+                <a:latin typeface="Arial"/>
+              </a:defRPr>
+            </a:pPr>
+            <a:r>
+              <a:t>Solves Mean-Variance quadratic optimization to find the highest Sharpe ratio while respecting liquidity bounds (Cash ≥ 5%).</a:t>
+            </a:r>
+          </a:p>
+          <a:p>
+            <a:pPr>
+              <a:spcAft>
+                <a:spcPts val="300"/>
+              </a:spcAft>
+              <a:defRPr sz="1600" b="1">
+                <a:solidFill>
+                  <a:srgbClr val="FFFFFF"/>
+                </a:solidFill>
+                <a:latin typeface="Arial"/>
+              </a:defRPr>
+            </a:pPr>
+            <a:r>
+              <a:t>• Engine 2: The Brakes (Risk Guardrail)</a:t>
+            </a:r>
+          </a:p>
+          <a:p>
+            <a:pPr>
+              <a:spcAft>
+                <a:spcPts val="1000"/>
+              </a:spcAft>
+              <a:defRPr sz="1400" b="0">
+                <a:solidFill>
+                  <a:srgbClr val="CBD5E1"/>
+                </a:solidFill>
+                <a:latin typeface="Arial"/>
+              </a:defRPr>
+            </a:pPr>
+            <a:r>
+              <a:t>Independent safety governor tracking tail risk (CVaR 95%, VaR, Drawdown, HHI). It holds complete veto power over allocations.</a:t>
+            </a:r>
+          </a:p>
+          <a:p>
+            <a:pPr>
+              <a:spcAft>
+                <a:spcPts val="300"/>
+              </a:spcAft>
+              <a:defRPr sz="1600" b="1">
+                <a:solidFill>
+                  <a:srgbClr val="FFFFFF"/>
+                </a:solidFill>
+                <a:latin typeface="Arial"/>
+              </a:defRPr>
+            </a:pPr>
+            <a:r>
+              <a:t>• Why Decoupled?</a:t>
+            </a:r>
+          </a:p>
+          <a:p>
+            <a:pPr>
+              <a:spcAft>
+                <a:spcPts val="0"/>
+              </a:spcAft>
+              <a:defRPr sz="1400" b="0">
+                <a:solidFill>
+                  <a:srgbClr val="CBD5E1"/>
+                </a:solidFill>
+                <a:latin typeface="Arial"/>
+              </a:defRPr>
+            </a:pPr>
+            <a:r>
+              <a:t>Putting CVaR directly into the optimizer causes mathematical instability. Keeping them separate makes it robust and lightning fast.</a:t>
+            </a:r>
+          </a:p>
+        </p:txBody>
+      </p:sp>
+      <p:sp>
+        <p:nvSpPr>
+          <p:cNvPr id="13" name="Rounded Rectangle 12"/>
+          <p:cNvSpPr/>
+          <p:nvPr/>
+        </p:nvSpPr>
+        <p:spPr>
+          <a:xfrm>
+            <a:off x="12344400" y="1920240"/>
+            <a:ext cx="5029200" cy="7680960"/>
+          </a:xfrm>
+          <a:prstGeom prst="roundRect">
+            <a:avLst/>
+          </a:prstGeom>
+          <a:solidFill>
+            <a:srgbClr val="0F172A"/>
+          </a:solidFill>
+          <a:ln w="19050">
+            <a:solidFill>
+              <a:srgbClr val="10B981"/>
+            </a:solidFill>
+          </a:ln>
+        </p:spPr>
+        <p:style>
+          <a:lnRef idx="1">
+            <a:schemeClr val="accent1"/>
+          </a:lnRef>
+          <a:fillRef idx="3">
+            <a:schemeClr val="accent1"/>
+          </a:fillRef>
+          <a:effectRef idx="2">
+            <a:schemeClr val="accent1"/>
+          </a:effectRef>
+          <a:fontRef idx="minor">
+            <a:schemeClr val="lt1"/>
+          </a:fontRef>
+        </p:style>
+        <p:txBody>
+          <a:bodyPr rtlCol="0" anchor="ctr" wrap="square" lIns="228600" rIns="228600" tIns="228600" bIns="228600"/>
+          <a:lstStyle/>
+          <a:p>
+            <a:pPr algn="ctr">
+              <a:spcAft>
+                <a:spcPts val="1000"/>
+              </a:spcAft>
+              <a:defRPr sz="1800" b="1">
+                <a:solidFill>
+                  <a:srgbClr val="34D399"/>
+                </a:solidFill>
+                <a:latin typeface="Arial"/>
+              </a:defRPr>
+            </a:pPr>
+            <a:r>
+              <a:t>3. 4-TIER GRADUATED SAFETY GUARDRAIL</a:t>
+            </a:r>
+          </a:p>
+          <a:p>
+            <a:pPr>
+              <a:spcAft>
+                <a:spcPts val="1200"/>
+              </a:spcAft>
+              <a:defRPr sz="1400" b="0">
+                <a:solidFill>
+                  <a:srgbClr val="94A3B8"/>
+                </a:solidFill>
+                <a:latin typeface="Arial"/>
+              </a:defRPr>
+            </a:pPr>
+            <a:r>
+              <a:t>Smart escalation instead of naive on/off alarms:</a:t>
+            </a:r>
+          </a:p>
+          <a:p>
+            <a:pPr>
+              <a:spcAft>
+                <a:spcPts val="200"/>
+              </a:spcAft>
+              <a:defRPr sz="1500" b="1">
+                <a:solidFill>
+                  <a:srgbClr val="34D399"/>
+                </a:solidFill>
+                <a:latin typeface="Arial"/>
+              </a:defRPr>
+            </a:pPr>
+            <a:r>
+              <a:t>[MONITOR] Normal Operation (Green)</a:t>
+            </a:r>
+          </a:p>
+          <a:p>
+            <a:pPr>
+              <a:spcAft>
+                <a:spcPts val="800"/>
+              </a:spcAft>
+              <a:defRPr sz="1350" b="0">
+                <a:solidFill>
+                  <a:srgbClr val="CBD5E1"/>
+                </a:solidFill>
+                <a:latin typeface="Arial"/>
+              </a:defRPr>
+            </a:pPr>
+            <a:r>
+              <a:t>All metrics within bounds. Zero rebalancing drag. Let compounding do its work.</a:t>
+            </a:r>
+          </a:p>
+          <a:p>
+            <a:pPr>
+              <a:spcAft>
+                <a:spcPts val="200"/>
+              </a:spcAft>
+              <a:defRPr sz="1500" b="1">
+                <a:solidFill>
+                  <a:srgbClr val="FBBF24"/>
+                </a:solidFill>
+                <a:latin typeface="Arial"/>
+              </a:defRPr>
+            </a:pPr>
+            <a:r>
+              <a:t>[WARN] Heightened Sensitivity (Yellow)</a:t>
+            </a:r>
+          </a:p>
+          <a:p>
+            <a:pPr>
+              <a:spcAft>
+                <a:spcPts val="800"/>
+              </a:spcAft>
+              <a:defRPr sz="1350" b="0">
+                <a:solidFill>
+                  <a:srgbClr val="CBD5E1"/>
+                </a:solidFill>
+                <a:latin typeface="Arial"/>
+              </a:defRPr>
+            </a:pPr>
+            <a:r>
+              <a:t>Any risk metric crosses 80% limit. Engine tightens sensitivity and monitors assets closer.</a:t>
+            </a:r>
+          </a:p>
+          <a:p>
+            <a:pPr>
+              <a:spcAft>
+                <a:spcPts val="200"/>
+              </a:spcAft>
+              <a:defRPr sz="1500" b="1">
+                <a:solidFill>
+                  <a:srgbClr val="F87171"/>
+                </a:solidFill>
+                <a:latin typeface="Arial"/>
+              </a:defRPr>
+            </a:pPr>
+            <a:r>
+              <a:t>[ACT] Autonomous De-Risking (Red)</a:t>
+            </a:r>
+          </a:p>
+          <a:p>
+            <a:pPr>
+              <a:spcAft>
+                <a:spcPts val="800"/>
+              </a:spcAft>
+              <a:defRPr sz="1350" b="0">
+                <a:solidFill>
+                  <a:srgbClr val="CBD5E1"/>
+                </a:solidFill>
+                <a:latin typeface="Arial"/>
+              </a:defRPr>
+            </a:pPr>
+            <a:r>
+              <a:t>Metric breaches safety limit. Automatically trims volatile assets into Cash.</a:t>
+            </a:r>
+          </a:p>
+          <a:p>
+            <a:pPr>
+              <a:spcAft>
+                <a:spcPts val="200"/>
+              </a:spcAft>
+              <a:defRPr sz="1500" b="1">
+                <a:solidFill>
+                  <a:srgbClr val="E2E8F0"/>
+                </a:solidFill>
+                <a:latin typeface="Arial"/>
+              </a:defRPr>
+            </a:pPr>
+            <a:r>
+              <a:t>[CIRCUIT BREAK] Defensive Lockdown (Black)</a:t>
+            </a:r>
+          </a:p>
+          <a:p>
+            <a:pPr>
+              <a:spcAft>
+                <a:spcPts val="0"/>
+              </a:spcAft>
+              <a:defRPr sz="1350" b="0">
+                <a:solidFill>
+                  <a:srgbClr val="CBD5E1"/>
+                </a:solidFill>
+                <a:latin typeface="Arial"/>
+              </a:defRPr>
+            </a:pPr>
+            <a:r>
+              <a:t>Extreme market shock. Emergency capital-preservation override into Cash &amp; Treasury Bonds.</a:t>
+            </a:r>
+          </a:p>
+        </p:txBody>
+      </p:sp>
     </p:spTree>
   </p:cSld>
   <p:clrMapOvr>
@@ -6282,6 +7004,552 @@
       <p:sp>
         <p:nvSpPr>
           <p:cNvPr id="10" name="Rounded Rectangle 9"/>
+          <p:cNvSpPr/>
+          <p:nvPr/>
+        </p:nvSpPr>
+        <p:spPr>
+          <a:xfrm>
+            <a:off x="12344400" y="1920240"/>
+            <a:ext cx="5029200" cy="7680960"/>
+          </a:xfrm>
+          <a:prstGeom prst="roundRect">
+            <a:avLst/>
+          </a:prstGeom>
+          <a:solidFill>
+            <a:srgbClr val="0F172A"/>
+          </a:solidFill>
+          <a:ln w="19050">
+            <a:solidFill>
+              <a:srgbClr val="A855F7"/>
+            </a:solidFill>
+          </a:ln>
+        </p:spPr>
+        <p:style>
+          <a:lnRef idx="1">
+            <a:schemeClr val="accent1"/>
+          </a:lnRef>
+          <a:fillRef idx="3">
+            <a:schemeClr val="accent1"/>
+          </a:fillRef>
+          <a:effectRef idx="2">
+            <a:schemeClr val="accent1"/>
+          </a:effectRef>
+          <a:fontRef idx="minor">
+            <a:schemeClr val="lt1"/>
+          </a:fontRef>
+        </p:style>
+        <p:txBody>
+          <a:bodyPr rtlCol="0" anchor="ctr" wrap="square" lIns="228600" rIns="228600" tIns="228600" bIns="228600"/>
+          <a:lstStyle/>
+          <a:p>
+            <a:pPr algn="ctr">
+              <a:spcAft>
+                <a:spcPts val="1000"/>
+              </a:spcAft>
+              <a:defRPr sz="1800" b="1">
+                <a:solidFill>
+                  <a:srgbClr val="D8B4FE"/>
+                </a:solidFill>
+                <a:latin typeface="Arial"/>
+              </a:defRPr>
+            </a:pPr>
+            <a:r>
+              <a:t>3. RISK GATING &amp; TECH ARCHITECTURE</a:t>
+            </a:r>
+          </a:p>
+          <a:p>
+            <a:pPr>
+              <a:spcAft>
+                <a:spcPts val="1200"/>
+              </a:spcAft>
+              <a:defRPr sz="1400" b="0">
+                <a:solidFill>
+                  <a:srgbClr val="94A3B8"/>
+                </a:solidFill>
+                <a:latin typeface="Arial"/>
+              </a:defRPr>
+            </a:pPr>
+            <a:r>
+              <a:t>Institutional math made practical:</a:t>
+            </a:r>
+          </a:p>
+          <a:p>
+            <a:pPr>
+              <a:spcAft>
+                <a:spcPts val="400"/>
+              </a:spcAft>
+              <a:defRPr sz="1500" b="1">
+                <a:solidFill>
+                  <a:srgbClr val="FFFFFF"/>
+                </a:solidFill>
+                <a:latin typeface="Arial"/>
+              </a:defRPr>
+            </a:pPr>
+            <a:r>
+              <a:t>• 95% CVaR (Expected Shortfall):</a:t>
+            </a:r>
+          </a:p>
+          <a:p>
+            <a:pPr>
+              <a:spcAft>
+                <a:spcPts val="1000"/>
+              </a:spcAft>
+              <a:defRPr sz="1400" b="0">
+                <a:solidFill>
+                  <a:srgbClr val="CBD5E1"/>
+                </a:solidFill>
+                <a:latin typeface="Arial"/>
+              </a:defRPr>
+            </a:pPr>
+            <a:r>
+              <a:t>Computed via rolling 60-day historical simulation (mean of worst 5% days). Answers: 'If the market crashes, how bad will it be?'</a:t>
+            </a:r>
+          </a:p>
+          <a:p>
+            <a:pPr>
+              <a:spcAft>
+                <a:spcPts val="400"/>
+              </a:spcAft>
+              <a:defRPr sz="1500" b="1">
+                <a:solidFill>
+                  <a:srgbClr val="FFFFFF"/>
+                </a:solidFill>
+                <a:latin typeface="Arial"/>
+              </a:defRPr>
+            </a:pPr>
+            <a:r>
+              <a:t>• Cholesky Correlated Simulator:</a:t>
+            </a:r>
+          </a:p>
+          <a:p>
+            <a:pPr>
+              <a:spcAft>
+                <a:spcPts val="1000"/>
+              </a:spcAft>
+              <a:defRPr sz="1400" b="0">
+                <a:solidFill>
+                  <a:srgbClr val="CBD5E1"/>
+                </a:solidFill>
+                <a:latin typeface="Arial"/>
+              </a:defRPr>
+            </a:pPr>
+            <a:r>
+              <a:t>Preserves cross-asset correlations (Equities vs Bonds vs Gold) rather than unrealistically assuming assets move independently.</a:t>
+            </a:r>
+          </a:p>
+          <a:p>
+            <a:pPr>
+              <a:spcAft>
+                <a:spcPts val="400"/>
+              </a:spcAft>
+              <a:defRPr sz="1500" b="1">
+                <a:solidFill>
+                  <a:srgbClr val="FFFFFF"/>
+                </a:solidFill>
+                <a:latin typeface="Arial"/>
+              </a:defRPr>
+            </a:pPr>
+            <a:r>
+              <a:t>• Modern Tech Stack:</a:t>
+            </a:r>
+          </a:p>
+          <a:p>
+            <a:pPr>
+              <a:spcAft>
+                <a:spcPts val="0"/>
+              </a:spcAft>
+              <a:defRPr sz="1400" b="0">
+                <a:solidFill>
+                  <a:srgbClr val="CBD5E1"/>
+                </a:solidFill>
+                <a:latin typeface="Arial"/>
+              </a:defRPr>
+            </a:pPr>
+            <a:r>
+              <a:t>FastAPI backend + 1.5s WebSockets + Chart.js dashboard. 40 automated tests pass in 0.25 seconds!</a:t>
+            </a:r>
+          </a:p>
+        </p:txBody>
+      </p:sp>
+      <p:sp>
+        <p:nvSpPr>
+          <p:cNvPr id="11" name="Rounded Rectangle 10"/>
+          <p:cNvSpPr/>
+          <p:nvPr/>
+        </p:nvSpPr>
+        <p:spPr>
+          <a:xfrm>
+            <a:off x="1463040" y="1920240"/>
+            <a:ext cx="5029200" cy="7680960"/>
+          </a:xfrm>
+          <a:prstGeom prst="roundRect">
+            <a:avLst/>
+          </a:prstGeom>
+          <a:solidFill>
+            <a:srgbClr val="0F172A"/>
+          </a:solidFill>
+          <a:ln w="19050">
+            <a:solidFill>
+              <a:srgbClr val="0EA5E9"/>
+            </a:solidFill>
+          </a:ln>
+        </p:spPr>
+        <p:style>
+          <a:lnRef idx="1">
+            <a:schemeClr val="accent1"/>
+          </a:lnRef>
+          <a:fillRef idx="3">
+            <a:schemeClr val="accent1"/>
+          </a:fillRef>
+          <a:effectRef idx="2">
+            <a:schemeClr val="accent1"/>
+          </a:effectRef>
+          <a:fontRef idx="minor">
+            <a:schemeClr val="lt1"/>
+          </a:fontRef>
+        </p:style>
+        <p:txBody>
+          <a:bodyPr rtlCol="0" anchor="ctr" wrap="square" lIns="228600" rIns="228600" tIns="228600" bIns="228600"/>
+          <a:lstStyle/>
+          <a:p>
+            <a:pPr algn="ctr">
+              <a:spcAft>
+                <a:spcPts val="1000"/>
+              </a:spcAft>
+              <a:defRPr sz="1800" b="1">
+                <a:solidFill>
+                  <a:srgbClr val="38BDF8"/>
+                </a:solidFill>
+                <a:latin typeface="Arial"/>
+              </a:defRPr>
+            </a:pPr>
+            <a:r>
+              <a:t>1. THE OPTIMIZATION FORMULATION</a:t>
+            </a:r>
+          </a:p>
+          <a:p>
+            <a:pPr>
+              <a:spcAft>
+                <a:spcPts val="1200"/>
+              </a:spcAft>
+              <a:defRPr sz="1400" b="0">
+                <a:solidFill>
+                  <a:srgbClr val="94A3B8"/>
+                </a:solidFill>
+                <a:latin typeface="Arial"/>
+              </a:defRPr>
+            </a:pPr>
+            <a:r>
+              <a:t>Clear, mathematically sound quadratic objective:</a:t>
+            </a:r>
+          </a:p>
+          <a:p>
+            <a:pPr>
+              <a:spcAft>
+                <a:spcPts val="400"/>
+              </a:spcAft>
+              <a:defRPr sz="1500" b="1">
+                <a:solidFill>
+                  <a:srgbClr val="FFFFFF"/>
+                </a:solidFill>
+                <a:latin typeface="Arial"/>
+              </a:defRPr>
+            </a:pPr>
+            <a:r>
+              <a:t>• The Optimization Formula:</a:t>
+            </a:r>
+          </a:p>
+          <a:p>
+            <a:pPr>
+              <a:spcAft>
+                <a:spcPts val="800"/>
+              </a:spcAft>
+              <a:defRPr sz="1400" b="1">
+                <a:solidFill>
+                  <a:srgbClr val="34D399"/>
+                </a:solidFill>
+                <a:latin typeface="Arial"/>
+              </a:defRPr>
+            </a:pPr>
+            <a:r>
+              <a:t>    max w [ μᵀw - (λ/2)·wᵀΣw - γ·Turnover ]</a:t>
+            </a:r>
+          </a:p>
+          <a:p>
+            <a:pPr>
+              <a:spcAft>
+                <a:spcPts val="400"/>
+              </a:spcAft>
+              <a:defRPr sz="1500" b="1">
+                <a:solidFill>
+                  <a:srgbClr val="FFFFFF"/>
+                </a:solidFill>
+                <a:latin typeface="Arial"/>
+              </a:defRPr>
+            </a:pPr>
+            <a:r>
+              <a:t>• Realistic Constraints We Enforce:</a:t>
+            </a:r>
+          </a:p>
+          <a:p>
+            <a:pPr>
+              <a:spcAft>
+                <a:spcPts val="1000"/>
+              </a:spcAft>
+              <a:defRPr sz="1400" b="0">
+                <a:solidFill>
+                  <a:srgbClr val="CBD5E1"/>
+                </a:solidFill>
+                <a:latin typeface="Arial"/>
+              </a:defRPr>
+            </a:pPr>
+            <a:r>
+              <a:t>  - Fully Invested: Σ wᵢ = 1.0</a:t>
+            </a:r>
+            <a:br/>
+            <a:r>
+              <a:t>  - Liquidity Guarantee: Cash ≥ 5%</a:t>
+            </a:r>
+            <a:br/>
+            <a:r>
+              <a:t>  - Anti-Concentration: Max single asset ≤ 45%</a:t>
+            </a:r>
+            <a:br/>
+            <a:r>
+              <a:t>  - Turnover Cap: Maximum 40% per rebalance</a:t>
+            </a:r>
+          </a:p>
+          <a:p>
+            <a:pPr>
+              <a:spcAft>
+                <a:spcPts val="400"/>
+              </a:spcAft>
+              <a:defRPr sz="1500" b="1">
+                <a:solidFill>
+                  <a:srgbClr val="FFFFFF"/>
+                </a:solidFill>
+                <a:latin typeface="Arial"/>
+              </a:defRPr>
+            </a:pPr>
+            <a:r>
+              <a:t>• Why SLSQP with Analytical Gradients?</a:t>
+            </a:r>
+          </a:p>
+          <a:p>
+            <a:pPr>
+              <a:spcAft>
+                <a:spcPts val="0"/>
+              </a:spcAft>
+              <a:defRPr sz="1400" b="0">
+                <a:solidFill>
+                  <a:srgbClr val="CBD5E1"/>
+                </a:solidFill>
+                <a:latin typeface="Arial"/>
+              </a:defRPr>
+            </a:pPr>
+            <a:r>
+              <a:t>By providing exact mathematical gradients (Jacobian) rather than numerical approximations, solver converges in just 11.4 milliseconds!</a:t>
+            </a:r>
+          </a:p>
+        </p:txBody>
+      </p:sp>
+      <p:sp>
+        <p:nvSpPr>
+          <p:cNvPr id="12" name="Rounded Rectangle 11"/>
+          <p:cNvSpPr/>
+          <p:nvPr/>
+        </p:nvSpPr>
+        <p:spPr>
+          <a:xfrm>
+            <a:off x="6903720" y="1920240"/>
+            <a:ext cx="5029200" cy="7680960"/>
+          </a:xfrm>
+          <a:prstGeom prst="roundRect">
+            <a:avLst/>
+          </a:prstGeom>
+          <a:solidFill>
+            <a:srgbClr val="0F172A"/>
+          </a:solidFill>
+          <a:ln w="19050">
+            <a:solidFill>
+              <a:srgbClr val="10B981"/>
+            </a:solidFill>
+          </a:ln>
+        </p:spPr>
+        <p:style>
+          <a:lnRef idx="1">
+            <a:schemeClr val="accent1"/>
+          </a:lnRef>
+          <a:fillRef idx="3">
+            <a:schemeClr val="accent1"/>
+          </a:fillRef>
+          <a:effectRef idx="2">
+            <a:schemeClr val="accent1"/>
+          </a:effectRef>
+          <a:fontRef idx="minor">
+            <a:schemeClr val="lt1"/>
+          </a:fontRef>
+        </p:style>
+        <p:txBody>
+          <a:bodyPr rtlCol="0" anchor="ctr" wrap="square" lIns="228600" rIns="228600" tIns="228600" bIns="228600"/>
+          <a:lstStyle/>
+          <a:p>
+            <a:pPr algn="ctr">
+              <a:spcAft>
+                <a:spcPts val="1000"/>
+              </a:spcAft>
+              <a:defRPr sz="1800" b="1">
+                <a:solidFill>
+                  <a:srgbClr val="34D399"/>
+                </a:solidFill>
+                <a:latin typeface="Arial"/>
+              </a:defRPr>
+            </a:pPr>
+            <a:r>
+              <a:t>2. SOLVING THE TRANSACTION COST DRAG</a:t>
+            </a:r>
+          </a:p>
+          <a:p>
+            <a:pPr>
+              <a:spcAft>
+                <a:spcPts val="1200"/>
+              </a:spcAft>
+              <a:defRPr sz="1400" b="0">
+                <a:solidFill>
+                  <a:srgbClr val="94A3B8"/>
+                </a:solidFill>
+                <a:latin typeface="Arial"/>
+              </a:defRPr>
+            </a:pPr>
+            <a:r>
+              <a:t>Answering the hackathon brief on rebalancing:</a:t>
+            </a:r>
+          </a:p>
+          <a:p>
+            <a:pPr>
+              <a:spcAft>
+                <a:spcPts val="400"/>
+              </a:spcAft>
+              <a:defRPr sz="1500" b="1">
+                <a:solidFill>
+                  <a:srgbClr val="FFFFFF"/>
+                </a:solidFill>
+                <a:latin typeface="Arial"/>
+              </a:defRPr>
+            </a:pPr>
+            <a:r>
+              <a:t>• The Big Question:</a:t>
+            </a:r>
+          </a:p>
+          <a:p>
+            <a:pPr>
+              <a:spcAft>
+                <a:spcPts val="1000"/>
+              </a:spcAft>
+              <a:defRPr sz="1400" b="1">
+                <a:solidFill>
+                  <a:srgbClr val="FBBF24"/>
+                </a:solidFill>
+                <a:latin typeface="Arial"/>
+              </a:defRPr>
+            </a:pPr>
+            <a:r>
+              <a:t>"How to balance allocation without incurring transaction penalties?"</a:t>
+            </a:r>
+          </a:p>
+          <a:p>
+            <a:pPr>
+              <a:spcAft>
+                <a:spcPts val="400"/>
+              </a:spcAft>
+              <a:defRPr sz="1500" b="1">
+                <a:solidFill>
+                  <a:srgbClr val="FFFFFF"/>
+                </a:solidFill>
+                <a:latin typeface="Arial"/>
+              </a:defRPr>
+            </a:pPr>
+            <a:r>
+              <a:t>• Our Answer: Adaptive Drift Gating:</a:t>
+            </a:r>
+          </a:p>
+          <a:p>
+            <a:pPr>
+              <a:spcAft>
+                <a:spcPts val="800"/>
+              </a:spcAft>
+              <a:defRPr sz="1400" b="0">
+                <a:solidFill>
+                  <a:srgbClr val="CBD5E1"/>
+                </a:solidFill>
+                <a:latin typeface="Arial"/>
+              </a:defRPr>
+            </a:pPr>
+            <a:r>
+              <a:t>Instead of trading every second, the optimizer ONLY acts when an asset drifts past a smart threshold:</a:t>
+            </a:r>
+          </a:p>
+          <a:p>
+            <a:pPr>
+              <a:spcAft>
+                <a:spcPts val="1000"/>
+              </a:spcAft>
+              <a:defRPr sz="1400" b="1">
+                <a:solidFill>
+                  <a:srgbClr val="FFFFFF"/>
+                </a:solidFill>
+                <a:latin typeface="Arial"/>
+              </a:defRPr>
+            </a:pPr>
+            <a:r>
+              <a:t>  - Calm Regime: 5.0% drift threshold</a:t>
+            </a:r>
+            <a:br/>
+            <a:r>
+              <a:t>  - Volatile Regime: 3.5% drift threshold</a:t>
+            </a:r>
+            <a:br/>
+            <a:r>
+              <a:t>  - Crisis Regime: 2.0% drift threshold</a:t>
+            </a:r>
+          </a:p>
+          <a:p>
+            <a:pPr>
+              <a:spcAft>
+                <a:spcPts val="400"/>
+              </a:spcAft>
+              <a:defRPr sz="1500" b="1">
+                <a:solidFill>
+                  <a:srgbClr val="FFFFFF"/>
+                </a:solidFill>
+                <a:latin typeface="Arial"/>
+              </a:defRPr>
+            </a:pPr>
+            <a:r>
+              <a:t>• Measurable Benefit:</a:t>
+            </a:r>
+          </a:p>
+          <a:p>
+            <a:pPr>
+              <a:spcAft>
+                <a:spcPts val="0"/>
+              </a:spcAft>
+              <a:defRPr sz="1400" b="0">
+                <a:solidFill>
+                  <a:srgbClr val="CBD5E1"/>
+                </a:solidFill>
+                <a:latin typeface="Arial"/>
+              </a:defRPr>
+            </a:pPr>
+            <a:r>
+              <a:t>Cuts 70%+ of unnecessary rebalancing trades, saving thousands in broker commissions.</a:t>
+            </a:r>
+          </a:p>
+        </p:txBody>
+      </p:sp>
+      <p:sp>
+        <p:nvSpPr>
+          <p:cNvPr id="13" name="Rounded Rectangle 12"/>
           <p:cNvSpPr/>
           <p:nvPr/>
         </p:nvSpPr>
@@ -7708,6 +8976,686 @@
       <p:sp>
         <p:nvSpPr>
           <p:cNvPr id="12" name="Rounded Rectangle 11"/>
+          <p:cNvSpPr/>
+          <p:nvPr/>
+        </p:nvSpPr>
+        <p:spPr>
+          <a:xfrm>
+            <a:off x="13587984" y="1920240"/>
+            <a:ext cx="3794760" cy="7680960"/>
+          </a:xfrm>
+          <a:prstGeom prst="roundRect">
+            <a:avLst/>
+          </a:prstGeom>
+          <a:solidFill>
+            <a:srgbClr val="0F172A"/>
+          </a:solidFill>
+          <a:ln w="19050">
+            <a:solidFill>
+              <a:srgbClr val="10B981"/>
+            </a:solidFill>
+          </a:ln>
+        </p:spPr>
+        <p:style>
+          <a:lnRef idx="1">
+            <a:schemeClr val="accent1"/>
+          </a:lnRef>
+          <a:fillRef idx="3">
+            <a:schemeClr val="accent1"/>
+          </a:fillRef>
+          <a:effectRef idx="2">
+            <a:schemeClr val="accent1"/>
+          </a:effectRef>
+          <a:fontRef idx="minor">
+            <a:schemeClr val="lt1"/>
+          </a:fontRef>
+        </p:style>
+        <p:txBody>
+          <a:bodyPr rtlCol="0" anchor="ctr" wrap="square" lIns="228600" rIns="228600" tIns="228600" bIns="228600"/>
+          <a:lstStyle/>
+          <a:p>
+            <a:pPr algn="ctr">
+              <a:spcAft>
+                <a:spcPts val="300"/>
+              </a:spcAft>
+              <a:defRPr sz="1400" b="1">
+                <a:solidFill>
+                  <a:srgbClr val="34D399"/>
+                </a:solidFill>
+                <a:latin typeface="Arial"/>
+              </a:defRPr>
+            </a:pPr>
+            <a:r>
+              <a:t>STEP 4</a:t>
+            </a:r>
+          </a:p>
+          <a:p>
+            <a:pPr>
+              <a:spcAft>
+                <a:spcPts val="1400"/>
+              </a:spcAft>
+              <a:defRPr sz="1700" b="1">
+                <a:solidFill>
+                  <a:srgbClr val="FFFFFF"/>
+                </a:solidFill>
+                <a:latin typeface="Arial"/>
+              </a:defRPr>
+            </a:pPr>
+            <a:r>
+              <a:t>HUMAN COCKPIT</a:t>
+            </a:r>
+          </a:p>
+          <a:p>
+            <a:pPr>
+              <a:spcAft>
+                <a:spcPts val="300"/>
+              </a:spcAft>
+              <a:defRPr sz="1500" b="1">
+                <a:solidFill>
+                  <a:srgbClr val="FFFFFF"/>
+                </a:solidFill>
+                <a:latin typeface="Arial"/>
+              </a:defRPr>
+            </a:pPr>
+            <a:r>
+              <a:t>• Plain-English Audit:</a:t>
+            </a:r>
+          </a:p>
+          <a:p>
+            <a:pPr>
+              <a:spcAft>
+                <a:spcPts val="1200"/>
+              </a:spcAft>
+              <a:defRPr sz="1350" b="0">
+                <a:solidFill>
+                  <a:srgbClr val="CBD5E1"/>
+                </a:solidFill>
+                <a:latin typeface="Arial"/>
+              </a:defRPr>
+            </a:pPr>
+            <a:r>
+              <a:t>Every trade logs an understandable reason in the Decision Audit Log.</a:t>
+            </a:r>
+          </a:p>
+          <a:p>
+            <a:pPr>
+              <a:spcAft>
+                <a:spcPts val="300"/>
+              </a:spcAft>
+              <a:defRPr sz="1500" b="1">
+                <a:solidFill>
+                  <a:srgbClr val="FFFFFF"/>
+                </a:solidFill>
+                <a:latin typeface="Arial"/>
+              </a:defRPr>
+            </a:pPr>
+            <a:r>
+              <a:t>• Visual Telemetry:</a:t>
+            </a:r>
+          </a:p>
+          <a:p>
+            <a:pPr>
+              <a:spcAft>
+                <a:spcPts val="1200"/>
+              </a:spcAft>
+              <a:defRPr sz="1350" b="0">
+                <a:solidFill>
+                  <a:srgbClr val="CBD5E1"/>
+                </a:solidFill>
+                <a:latin typeface="Arial"/>
+              </a:defRPr>
+            </a:pPr>
+            <a:r>
+              <a:t>WebSockets push live donut allocations, risk gauges, and NAV lines.</a:t>
+            </a:r>
+          </a:p>
+          <a:p>
+            <a:pPr>
+              <a:spcAft>
+                <a:spcPts val="300"/>
+              </a:spcAft>
+              <a:defRPr sz="1500" b="1">
+                <a:solidFill>
+                  <a:srgbClr val="FFFFFF"/>
+                </a:solidFill>
+                <a:latin typeface="Arial"/>
+              </a:defRPr>
+            </a:pPr>
+            <a:r>
+              <a:t>• What-If Simulator:</a:t>
+            </a:r>
+          </a:p>
+          <a:p>
+            <a:pPr>
+              <a:spcAft>
+                <a:spcPts val="1200"/>
+              </a:spcAft>
+              <a:defRPr sz="1350" b="0">
+                <a:solidFill>
+                  <a:srgbClr val="CBD5E1"/>
+                </a:solidFill>
+                <a:latin typeface="Arial"/>
+              </a:defRPr>
+            </a:pPr>
+            <a:r>
+              <a:t>Risk managers can stress-test any hypothetical crash scenario anytime.</a:t>
+            </a:r>
+          </a:p>
+        </p:txBody>
+      </p:sp>
+      <p:sp>
+        <p:nvSpPr>
+          <p:cNvPr id="13" name="Rounded Rectangle 12"/>
+          <p:cNvSpPr/>
+          <p:nvPr/>
+        </p:nvSpPr>
+        <p:spPr>
+          <a:xfrm>
+            <a:off x="1463040" y="1920240"/>
+            <a:ext cx="3794760" cy="7680960"/>
+          </a:xfrm>
+          <a:prstGeom prst="roundRect">
+            <a:avLst/>
+          </a:prstGeom>
+          <a:solidFill>
+            <a:srgbClr val="0F172A"/>
+          </a:solidFill>
+          <a:ln w="19050">
+            <a:solidFill>
+              <a:srgbClr val="0EA5E9"/>
+            </a:solidFill>
+          </a:ln>
+        </p:spPr>
+        <p:style>
+          <a:lnRef idx="1">
+            <a:schemeClr val="accent1"/>
+          </a:lnRef>
+          <a:fillRef idx="3">
+            <a:schemeClr val="accent1"/>
+          </a:fillRef>
+          <a:effectRef idx="2">
+            <a:schemeClr val="accent1"/>
+          </a:effectRef>
+          <a:fontRef idx="minor">
+            <a:schemeClr val="lt1"/>
+          </a:fontRef>
+        </p:style>
+        <p:txBody>
+          <a:bodyPr rtlCol="0" anchor="ctr" wrap="square" lIns="228600" rIns="228600" tIns="228600" bIns="228600"/>
+          <a:lstStyle/>
+          <a:p>
+            <a:pPr algn="ctr">
+              <a:spcAft>
+                <a:spcPts val="300"/>
+              </a:spcAft>
+              <a:defRPr sz="1400" b="1">
+                <a:solidFill>
+                  <a:srgbClr val="38BDF8"/>
+                </a:solidFill>
+                <a:latin typeface="Arial"/>
+              </a:defRPr>
+            </a:pPr>
+            <a:r>
+              <a:t>STEP 1</a:t>
+            </a:r>
+          </a:p>
+          <a:p>
+            <a:pPr>
+              <a:spcAft>
+                <a:spcPts val="1400"/>
+              </a:spcAft>
+              <a:defRPr sz="1700" b="1">
+                <a:solidFill>
+                  <a:srgbClr val="FFFFFF"/>
+                </a:solidFill>
+                <a:latin typeface="Arial"/>
+              </a:defRPr>
+            </a:pPr>
+            <a:r>
+              <a:t>MARKET INGESTION</a:t>
+            </a:r>
+          </a:p>
+          <a:p>
+            <a:pPr>
+              <a:spcAft>
+                <a:spcPts val="300"/>
+              </a:spcAft>
+              <a:defRPr sz="1500" b="1">
+                <a:solidFill>
+                  <a:srgbClr val="FFFFFF"/>
+                </a:solidFill>
+                <a:latin typeface="Arial"/>
+              </a:defRPr>
+            </a:pPr>
+            <a:r>
+              <a:t>• Every 1.5 Seconds:</a:t>
+            </a:r>
+          </a:p>
+          <a:p>
+            <a:pPr>
+              <a:spcAft>
+                <a:spcPts val="1200"/>
+              </a:spcAft>
+              <a:defRPr sz="1350" b="0">
+                <a:solidFill>
+                  <a:srgbClr val="CBD5E1"/>
+                </a:solidFill>
+                <a:latin typeface="Arial"/>
+              </a:defRPr>
+            </a:pPr>
+            <a:r>
+              <a:t>Correlated cross-asset price vector streams into the engine.</a:t>
+            </a:r>
+          </a:p>
+          <a:p>
+            <a:pPr>
+              <a:spcAft>
+                <a:spcPts val="300"/>
+              </a:spcAft>
+              <a:defRPr sz="1500" b="1">
+                <a:solidFill>
+                  <a:srgbClr val="FFFFFF"/>
+                </a:solidFill>
+                <a:latin typeface="Arial"/>
+              </a:defRPr>
+            </a:pPr>
+            <a:r>
+              <a:t>• Real Portfolio Valuation:</a:t>
+            </a:r>
+          </a:p>
+          <a:p>
+            <a:pPr>
+              <a:spcAft>
+                <a:spcPts val="1200"/>
+              </a:spcAft>
+              <a:defRPr sz="1350" b="0">
+                <a:solidFill>
+                  <a:srgbClr val="CBD5E1"/>
+                </a:solidFill>
+                <a:latin typeface="Arial"/>
+              </a:defRPr>
+            </a:pPr>
+            <a:r>
+              <a:t>Updates cash balance, asset market values, and NAV history in real time.</a:t>
+            </a:r>
+          </a:p>
+          <a:p>
+            <a:pPr>
+              <a:spcAft>
+                <a:spcPts val="300"/>
+              </a:spcAft>
+              <a:defRPr sz="1500" b="1">
+                <a:solidFill>
+                  <a:srgbClr val="FFFFFF"/>
+                </a:solidFill>
+                <a:latin typeface="Arial"/>
+              </a:defRPr>
+            </a:pPr>
+            <a:r>
+              <a:t>• No Lag:</a:t>
+            </a:r>
+          </a:p>
+          <a:p>
+            <a:pPr>
+              <a:spcAft>
+                <a:spcPts val="1200"/>
+              </a:spcAft>
+              <a:defRPr sz="1350" b="0">
+                <a:solidFill>
+                  <a:srgbClr val="CBD5E1"/>
+                </a:solidFill>
+                <a:latin typeface="Arial"/>
+              </a:defRPr>
+            </a:pPr>
+            <a:r>
+              <a:t>Event-driven pipeline processes mark-to-market data instantly.</a:t>
+            </a:r>
+          </a:p>
+        </p:txBody>
+      </p:sp>
+      <p:sp>
+        <p:nvSpPr>
+          <p:cNvPr id="14" name="Rounded Rectangle 13"/>
+          <p:cNvSpPr/>
+          <p:nvPr/>
+        </p:nvSpPr>
+        <p:spPr>
+          <a:xfrm>
+            <a:off x="5504688" y="1920240"/>
+            <a:ext cx="3794760" cy="7680960"/>
+          </a:xfrm>
+          <a:prstGeom prst="roundRect">
+            <a:avLst/>
+          </a:prstGeom>
+          <a:solidFill>
+            <a:srgbClr val="0F172A"/>
+          </a:solidFill>
+          <a:ln w="19050">
+            <a:solidFill>
+              <a:srgbClr val="F59E0B"/>
+            </a:solidFill>
+          </a:ln>
+        </p:spPr>
+        <p:style>
+          <a:lnRef idx="1">
+            <a:schemeClr val="accent1"/>
+          </a:lnRef>
+          <a:fillRef idx="3">
+            <a:schemeClr val="accent1"/>
+          </a:fillRef>
+          <a:effectRef idx="2">
+            <a:schemeClr val="accent1"/>
+          </a:effectRef>
+          <a:fontRef idx="minor">
+            <a:schemeClr val="lt1"/>
+          </a:fontRef>
+        </p:style>
+        <p:txBody>
+          <a:bodyPr rtlCol="0" anchor="ctr" wrap="square" lIns="228600" rIns="228600" tIns="228600" bIns="228600"/>
+          <a:lstStyle/>
+          <a:p>
+            <a:pPr algn="ctr">
+              <a:spcAft>
+                <a:spcPts val="300"/>
+              </a:spcAft>
+              <a:defRPr sz="1400" b="1">
+                <a:solidFill>
+                  <a:srgbClr val="FBBF24"/>
+                </a:solidFill>
+                <a:latin typeface="Arial"/>
+              </a:defRPr>
+            </a:pPr>
+            <a:r>
+              <a:t>STEP 2</a:t>
+            </a:r>
+          </a:p>
+          <a:p>
+            <a:pPr>
+              <a:spcAft>
+                <a:spcPts val="1400"/>
+              </a:spcAft>
+              <a:defRPr sz="1700" b="1">
+                <a:solidFill>
+                  <a:srgbClr val="FFFFFF"/>
+                </a:solidFill>
+                <a:latin typeface="Arial"/>
+              </a:defRPr>
+            </a:pPr>
+            <a:r>
+              <a:t>HEALTH &amp; TAIL CHECK</a:t>
+            </a:r>
+          </a:p>
+          <a:p>
+            <a:pPr>
+              <a:spcAft>
+                <a:spcPts val="300"/>
+              </a:spcAft>
+              <a:defRPr sz="1500" b="1">
+                <a:solidFill>
+                  <a:srgbClr val="FFFFFF"/>
+                </a:solidFill>
+                <a:latin typeface="Arial"/>
+              </a:defRPr>
+            </a:pPr>
+            <a:r>
+              <a:t>• O(1) Instant Math:</a:t>
+            </a:r>
+          </a:p>
+          <a:p>
+            <a:pPr>
+              <a:spcAft>
+                <a:spcPts val="1200"/>
+              </a:spcAft>
+              <a:defRPr sz="1350" b="0">
+                <a:solidFill>
+                  <a:srgbClr val="CBD5E1"/>
+                </a:solidFill>
+                <a:latin typeface="Arial"/>
+              </a:defRPr>
+            </a:pPr>
+            <a:r>
+              <a:t>Computes VaR (95%), CVaR (95%), Peak-to-Trough Drawdown, and HHI.</a:t>
+            </a:r>
+          </a:p>
+          <a:p>
+            <a:pPr>
+              <a:spcAft>
+                <a:spcPts val="300"/>
+              </a:spcAft>
+              <a:defRPr sz="1500" b="1">
+                <a:solidFill>
+                  <a:srgbClr val="FFFFFF"/>
+                </a:solidFill>
+                <a:latin typeface="Arial"/>
+              </a:defRPr>
+            </a:pPr>
+            <a:r>
+              <a:t>• Dynamic Limits:</a:t>
+            </a:r>
+          </a:p>
+          <a:p>
+            <a:pPr>
+              <a:spcAft>
+                <a:spcPts val="1200"/>
+              </a:spcAft>
+              <a:defRPr sz="1350" b="0">
+                <a:solidFill>
+                  <a:srgbClr val="CBD5E1"/>
+                </a:solidFill>
+                <a:latin typeface="Arial"/>
+              </a:defRPr>
+            </a:pPr>
+            <a:r>
+              <a:t>Checks risk against regime-adjusted safety bounds.</a:t>
+            </a:r>
+          </a:p>
+          <a:p>
+            <a:pPr>
+              <a:spcAft>
+                <a:spcPts val="300"/>
+              </a:spcAft>
+              <a:defRPr sz="1500" b="1">
+                <a:solidFill>
+                  <a:srgbClr val="FFFFFF"/>
+                </a:solidFill>
+                <a:latin typeface="Arial"/>
+              </a:defRPr>
+            </a:pPr>
+            <a:r>
+              <a:t>• Early Warning:</a:t>
+            </a:r>
+          </a:p>
+          <a:p>
+            <a:pPr>
+              <a:spcAft>
+                <a:spcPts val="1200"/>
+              </a:spcAft>
+              <a:defRPr sz="1350" b="0">
+                <a:solidFill>
+                  <a:srgbClr val="CBD5E1"/>
+                </a:solidFill>
+                <a:latin typeface="Arial"/>
+              </a:defRPr>
+            </a:pPr>
+            <a:r>
+              <a:t>Flags yellow caution when metrics approach 80% threshold.</a:t>
+            </a:r>
+          </a:p>
+        </p:txBody>
+      </p:sp>
+      <p:sp>
+        <p:nvSpPr>
+          <p:cNvPr id="15" name="Rounded Rectangle 14"/>
+          <p:cNvSpPr/>
+          <p:nvPr/>
+        </p:nvSpPr>
+        <p:spPr>
+          <a:xfrm>
+            <a:off x="9546336" y="1920240"/>
+            <a:ext cx="3794760" cy="7680960"/>
+          </a:xfrm>
+          <a:prstGeom prst="roundRect">
+            <a:avLst/>
+          </a:prstGeom>
+          <a:solidFill>
+            <a:srgbClr val="0F172A"/>
+          </a:solidFill>
+          <a:ln w="19050">
+            <a:solidFill>
+              <a:srgbClr val="EF4444"/>
+            </a:solidFill>
+          </a:ln>
+        </p:spPr>
+        <p:style>
+          <a:lnRef idx="1">
+            <a:schemeClr val="accent1"/>
+          </a:lnRef>
+          <a:fillRef idx="3">
+            <a:schemeClr val="accent1"/>
+          </a:fillRef>
+          <a:effectRef idx="2">
+            <a:schemeClr val="accent1"/>
+          </a:effectRef>
+          <a:fontRef idx="minor">
+            <a:schemeClr val="lt1"/>
+          </a:fontRef>
+        </p:style>
+        <p:txBody>
+          <a:bodyPr rtlCol="0" anchor="ctr" wrap="square" lIns="228600" rIns="228600" tIns="228600" bIns="228600"/>
+          <a:lstStyle/>
+          <a:p>
+            <a:pPr algn="ctr">
+              <a:spcAft>
+                <a:spcPts val="300"/>
+              </a:spcAft>
+              <a:defRPr sz="1400" b="1">
+                <a:solidFill>
+                  <a:srgbClr val="F87171"/>
+                </a:solidFill>
+                <a:latin typeface="Arial"/>
+              </a:defRPr>
+            </a:pPr>
+            <a:r>
+              <a:t>STEP 3</a:t>
+            </a:r>
+          </a:p>
+          <a:p>
+            <a:pPr>
+              <a:spcAft>
+                <a:spcPts val="1400"/>
+              </a:spcAft>
+              <a:defRPr sz="1700" b="1">
+                <a:solidFill>
+                  <a:srgbClr val="FFFFFF"/>
+                </a:solidFill>
+                <a:latin typeface="Arial"/>
+              </a:defRPr>
+            </a:pPr>
+            <a:r>
+              <a:t>GUARDRAIL ACTION</a:t>
+            </a:r>
+          </a:p>
+          <a:p>
+            <a:pPr>
+              <a:spcAft>
+                <a:spcPts val="300"/>
+              </a:spcAft>
+              <a:defRPr sz="1500" b="1">
+                <a:solidFill>
+                  <a:srgbClr val="FFFFFF"/>
+                </a:solidFill>
+                <a:latin typeface="Arial"/>
+              </a:defRPr>
+            </a:pPr>
+            <a:r>
+              <a:t>• Safety First Priority:</a:t>
+            </a:r>
+          </a:p>
+          <a:p>
+            <a:pPr>
+              <a:spcAft>
+                <a:spcPts val="1200"/>
+              </a:spcAft>
+              <a:defRPr sz="1350" b="0">
+                <a:solidFill>
+                  <a:srgbClr val="CBD5E1"/>
+                </a:solidFill>
+                <a:latin typeface="Arial"/>
+              </a:defRPr>
+            </a:pPr>
+            <a:r>
+              <a:t>If risk limit breached: forces immediate de-risking into Cash/Bonds.</a:t>
+            </a:r>
+          </a:p>
+          <a:p>
+            <a:pPr>
+              <a:spcAft>
+                <a:spcPts val="300"/>
+              </a:spcAft>
+              <a:defRPr sz="1500" b="1">
+                <a:solidFill>
+                  <a:srgbClr val="FFFFFF"/>
+                </a:solidFill>
+                <a:latin typeface="Arial"/>
+              </a:defRPr>
+            </a:pPr>
+            <a:r>
+              <a:t>• Smart Drift Check:</a:t>
+            </a:r>
+          </a:p>
+          <a:p>
+            <a:pPr>
+              <a:spcAft>
+                <a:spcPts val="1200"/>
+              </a:spcAft>
+              <a:defRPr sz="1350" b="0">
+                <a:solidFill>
+                  <a:srgbClr val="CBD5E1"/>
+                </a:solidFill>
+                <a:latin typeface="Arial"/>
+              </a:defRPr>
+            </a:pPr>
+            <a:r>
+              <a:t>If safe: checks asset drift. Only rebalances if max drift &gt; threshold.</a:t>
+            </a:r>
+          </a:p>
+          <a:p>
+            <a:pPr>
+              <a:spcAft>
+                <a:spcPts val="300"/>
+              </a:spcAft>
+              <a:defRPr sz="1500" b="1">
+                <a:solidFill>
+                  <a:srgbClr val="FFFFFF"/>
+                </a:solidFill>
+                <a:latin typeface="Arial"/>
+              </a:defRPr>
+            </a:pPr>
+            <a:r>
+              <a:t>• Zero Fee Drag:</a:t>
+            </a:r>
+          </a:p>
+          <a:p>
+            <a:pPr>
+              <a:spcAft>
+                <a:spcPts val="1200"/>
+              </a:spcAft>
+              <a:defRPr sz="1350" b="0">
+                <a:solidFill>
+                  <a:srgbClr val="CBD5E1"/>
+                </a:solidFill>
+                <a:latin typeface="Arial"/>
+              </a:defRPr>
+            </a:pPr>
+            <a:r>
+              <a:t>Ignores micro-wiggles to prevent unnecessary broker transaction fees.</a:t>
+            </a:r>
+          </a:p>
+        </p:txBody>
+      </p:sp>
+      <p:sp>
+        <p:nvSpPr>
+          <p:cNvPr id="16" name="Rounded Rectangle 15"/>
           <p:cNvSpPr/>
           <p:nvPr/>
         </p:nvSpPr>
@@ -8704,6 +10652,398 @@
       <p:pic>
         <p:nvPicPr>
           <p:cNvPr id="20" name="Picture 19" descr="image.png"/>
+          <p:cNvPicPr>
+            <a:picLocks noChangeAspect="1"/>
+          </p:cNvPicPr>
+          <p:nvPr/>
+        </p:nvPicPr>
+        <p:blipFill>
+          <a:blip r:embed="rId5"/>
+          <a:stretch>
+            <a:fillRect/>
+          </a:stretch>
+        </p:blipFill>
+        <p:spPr>
+          <a:xfrm>
+            <a:off x="9784080" y="6583680"/>
+            <a:ext cx="7406640" cy="2697480"/>
+          </a:xfrm>
+          <a:prstGeom prst="rect">
+            <a:avLst/>
+          </a:prstGeom>
+        </p:spPr>
+      </p:pic>
+      <p:sp>
+        <p:nvSpPr>
+          <p:cNvPr id="21" name="Rounded Rectangle 20"/>
+          <p:cNvSpPr/>
+          <p:nvPr/>
+        </p:nvSpPr>
+        <p:spPr>
+          <a:xfrm>
+            <a:off x="1463040" y="1920240"/>
+            <a:ext cx="7772400" cy="3657600"/>
+          </a:xfrm>
+          <a:prstGeom prst="roundRect">
+            <a:avLst/>
+          </a:prstGeom>
+          <a:solidFill>
+            <a:srgbClr val="0F172A"/>
+          </a:solidFill>
+          <a:ln w="19050">
+            <a:solidFill>
+              <a:srgbClr val="0EA5E9"/>
+            </a:solidFill>
+          </a:ln>
+        </p:spPr>
+        <p:style>
+          <a:lnRef idx="1">
+            <a:schemeClr val="accent1"/>
+          </a:lnRef>
+          <a:fillRef idx="3">
+            <a:schemeClr val="accent1"/>
+          </a:fillRef>
+          <a:effectRef idx="2">
+            <a:schemeClr val="accent1"/>
+          </a:effectRef>
+          <a:fontRef idx="minor">
+            <a:schemeClr val="lt1"/>
+          </a:fontRef>
+        </p:style>
+        <p:txBody>
+          <a:bodyPr rtlCol="0" anchor="ctr" wrap="square" lIns="228600" rIns="228600" tIns="228600" bIns="228600"/>
+          <a:lstStyle/>
+          <a:p>
+            <a:pPr algn="ctr">
+              <a:spcAft>
+                <a:spcPts val="200"/>
+              </a:spcAft>
+              <a:defRPr sz="1400" b="1">
+                <a:solidFill>
+                  <a:srgbClr val="38BDF8"/>
+                </a:solidFill>
+                <a:latin typeface="Arial"/>
+              </a:defRPr>
+            </a:pPr>
+            <a:r>
+              <a:t>Live Institutional Cockpit &amp; NAV Chart</a:t>
+            </a:r>
+          </a:p>
+          <a:p>
+            <a:pPr>
+              <a:spcAft>
+                <a:spcPts val="400"/>
+              </a:spcAft>
+              <a:defRPr sz="1200" b="0">
+                <a:solidFill>
+                  <a:srgbClr val="94A3B8"/>
+                </a:solidFill>
+                <a:latin typeface="Arial"/>
+              </a:defRPr>
+            </a:pPr>
+            <a:r>
+              <a:t>Pulsing Guardrail banner (🟢 MONITOR), top KPIs, and dynamic line chart.</a:t>
+            </a:r>
+          </a:p>
+        </p:txBody>
+      </p:sp>
+      <p:pic>
+        <p:nvPicPr>
+          <p:cNvPr id="22" name="Picture 21" descr="image.png"/>
+          <p:cNvPicPr>
+            <a:picLocks noChangeAspect="1"/>
+          </p:cNvPicPr>
+          <p:nvPr/>
+        </p:nvPicPr>
+        <p:blipFill>
+          <a:blip r:embed="rId2"/>
+          <a:stretch>
+            <a:fillRect/>
+          </a:stretch>
+        </p:blipFill>
+        <p:spPr>
+          <a:xfrm>
+            <a:off x="1645920" y="2743200"/>
+            <a:ext cx="7406640" cy="2697480"/>
+          </a:xfrm>
+          <a:prstGeom prst="rect">
+            <a:avLst/>
+          </a:prstGeom>
+        </p:spPr>
+      </p:pic>
+      <p:sp>
+        <p:nvSpPr>
+          <p:cNvPr id="23" name="Rounded Rectangle 22"/>
+          <p:cNvSpPr/>
+          <p:nvPr/>
+        </p:nvSpPr>
+        <p:spPr>
+          <a:xfrm>
+            <a:off x="9601200" y="1920240"/>
+            <a:ext cx="7772400" cy="3657600"/>
+          </a:xfrm>
+          <a:prstGeom prst="roundRect">
+            <a:avLst/>
+          </a:prstGeom>
+          <a:solidFill>
+            <a:srgbClr val="0F172A"/>
+          </a:solidFill>
+          <a:ln w="19050">
+            <a:solidFill>
+              <a:srgbClr val="0EA5E9"/>
+            </a:solidFill>
+          </a:ln>
+        </p:spPr>
+        <p:style>
+          <a:lnRef idx="1">
+            <a:schemeClr val="accent1"/>
+          </a:lnRef>
+          <a:fillRef idx="3">
+            <a:schemeClr val="accent1"/>
+          </a:fillRef>
+          <a:effectRef idx="2">
+            <a:schemeClr val="accent1"/>
+          </a:effectRef>
+          <a:fontRef idx="minor">
+            <a:schemeClr val="lt1"/>
+          </a:fontRef>
+        </p:style>
+        <p:txBody>
+          <a:bodyPr rtlCol="0" anchor="ctr" wrap="square" lIns="228600" rIns="228600" tIns="228600" bIns="228600"/>
+          <a:lstStyle/>
+          <a:p>
+            <a:pPr algn="ctr">
+              <a:spcAft>
+                <a:spcPts val="200"/>
+              </a:spcAft>
+              <a:defRPr sz="1400" b="1">
+                <a:solidFill>
+                  <a:srgbClr val="38BDF8"/>
+                </a:solidFill>
+                <a:latin typeface="Arial"/>
+              </a:defRPr>
+            </a:pPr>
+            <a:r>
+              <a:t>Asset Allocation Donut &amp; Live Drift Meters</a:t>
+            </a:r>
+          </a:p>
+          <a:p>
+            <a:pPr>
+              <a:spcAft>
+                <a:spcPts val="400"/>
+              </a:spcAft>
+              <a:defRPr sz="1200" b="0">
+                <a:solidFill>
+                  <a:srgbClr val="94A3B8"/>
+                </a:solidFill>
+                <a:latin typeface="Arial"/>
+              </a:defRPr>
+            </a:pPr>
+            <a:r>
+              <a:t>Donut breakdown across 6 asset classes with real-time drift indicators.</a:t>
+            </a:r>
+          </a:p>
+        </p:txBody>
+      </p:sp>
+      <p:pic>
+        <p:nvPicPr>
+          <p:cNvPr id="24" name="Picture 23" descr="image.png"/>
+          <p:cNvPicPr>
+            <a:picLocks noChangeAspect="1"/>
+          </p:cNvPicPr>
+          <p:nvPr/>
+        </p:nvPicPr>
+        <p:blipFill>
+          <a:blip r:embed="rId3"/>
+          <a:stretch>
+            <a:fillRect/>
+          </a:stretch>
+        </p:blipFill>
+        <p:spPr>
+          <a:xfrm>
+            <a:off x="9784080" y="2743200"/>
+            <a:ext cx="7406640" cy="2697480"/>
+          </a:xfrm>
+          <a:prstGeom prst="rect">
+            <a:avLst/>
+          </a:prstGeom>
+        </p:spPr>
+      </p:pic>
+      <p:sp>
+        <p:nvSpPr>
+          <p:cNvPr id="25" name="Rounded Rectangle 24"/>
+          <p:cNvSpPr/>
+          <p:nvPr/>
+        </p:nvSpPr>
+        <p:spPr>
+          <a:xfrm>
+            <a:off x="1463040" y="5760720"/>
+            <a:ext cx="7772400" cy="3657600"/>
+          </a:xfrm>
+          <a:prstGeom prst="roundRect">
+            <a:avLst/>
+          </a:prstGeom>
+          <a:solidFill>
+            <a:srgbClr val="0F172A"/>
+          </a:solidFill>
+          <a:ln w="19050">
+            <a:solidFill>
+              <a:srgbClr val="0EA5E9"/>
+            </a:solidFill>
+          </a:ln>
+        </p:spPr>
+        <p:style>
+          <a:lnRef idx="1">
+            <a:schemeClr val="accent1"/>
+          </a:lnRef>
+          <a:fillRef idx="3">
+            <a:schemeClr val="accent1"/>
+          </a:fillRef>
+          <a:effectRef idx="2">
+            <a:schemeClr val="accent1"/>
+          </a:effectRef>
+          <a:fontRef idx="minor">
+            <a:schemeClr val="lt1"/>
+          </a:fontRef>
+        </p:style>
+        <p:txBody>
+          <a:bodyPr rtlCol="0" anchor="ctr" wrap="square" lIns="228600" rIns="228600" tIns="228600" bIns="228600"/>
+          <a:lstStyle/>
+          <a:p>
+            <a:pPr algn="ctr">
+              <a:spcAft>
+                <a:spcPts val="200"/>
+              </a:spcAft>
+              <a:defRPr sz="1400" b="1">
+                <a:solidFill>
+                  <a:srgbClr val="38BDF8"/>
+                </a:solidFill>
+                <a:latin typeface="Arial"/>
+              </a:defRPr>
+            </a:pPr>
+            <a:r>
+              <a:t>Interactive What-If Scenario Simulator</a:t>
+            </a:r>
+          </a:p>
+          <a:p>
+            <a:pPr>
+              <a:spcAft>
+                <a:spcPts val="400"/>
+              </a:spcAft>
+              <a:defRPr sz="1200" b="0">
+                <a:solidFill>
+                  <a:srgbClr val="94A3B8"/>
+                </a:solidFill>
+                <a:latin typeface="Arial"/>
+              </a:defRPr>
+            </a:pPr>
+            <a:r>
+              <a:t>Allows risk managers to dial in custom market shocks and observe projected impact.</a:t>
+            </a:r>
+          </a:p>
+        </p:txBody>
+      </p:sp>
+      <p:pic>
+        <p:nvPicPr>
+          <p:cNvPr id="26" name="Picture 25" descr="image.png"/>
+          <p:cNvPicPr>
+            <a:picLocks noChangeAspect="1"/>
+          </p:cNvPicPr>
+          <p:nvPr/>
+        </p:nvPicPr>
+        <p:blipFill>
+          <a:blip r:embed="rId4"/>
+          <a:stretch>
+            <a:fillRect/>
+          </a:stretch>
+        </p:blipFill>
+        <p:spPr>
+          <a:xfrm>
+            <a:off x="1645920" y="6583680"/>
+            <a:ext cx="7406640" cy="2697480"/>
+          </a:xfrm>
+          <a:prstGeom prst="rect">
+            <a:avLst/>
+          </a:prstGeom>
+        </p:spPr>
+      </p:pic>
+      <p:sp>
+        <p:nvSpPr>
+          <p:cNvPr id="27" name="Rounded Rectangle 26"/>
+          <p:cNvSpPr/>
+          <p:nvPr/>
+        </p:nvSpPr>
+        <p:spPr>
+          <a:xfrm>
+            <a:off x="9601200" y="5760720"/>
+            <a:ext cx="7772400" cy="3657600"/>
+          </a:xfrm>
+          <a:prstGeom prst="roundRect">
+            <a:avLst/>
+          </a:prstGeom>
+          <a:solidFill>
+            <a:srgbClr val="0F172A"/>
+          </a:solidFill>
+          <a:ln w="19050">
+            <a:solidFill>
+              <a:srgbClr val="0EA5E9"/>
+            </a:solidFill>
+          </a:ln>
+        </p:spPr>
+        <p:style>
+          <a:lnRef idx="1">
+            <a:schemeClr val="accent1"/>
+          </a:lnRef>
+          <a:fillRef idx="3">
+            <a:schemeClr val="accent1"/>
+          </a:fillRef>
+          <a:effectRef idx="2">
+            <a:schemeClr val="accent1"/>
+          </a:effectRef>
+          <a:fontRef idx="minor">
+            <a:schemeClr val="lt1"/>
+          </a:fontRef>
+        </p:style>
+        <p:txBody>
+          <a:bodyPr rtlCol="0" anchor="ctr" wrap="square" lIns="228600" rIns="228600" tIns="228600" bIns="228600"/>
+          <a:lstStyle/>
+          <a:p>
+            <a:pPr algn="ctr">
+              <a:spcAft>
+                <a:spcPts val="200"/>
+              </a:spcAft>
+              <a:defRPr sz="1400" b="1">
+                <a:solidFill>
+                  <a:srgbClr val="38BDF8"/>
+                </a:solidFill>
+                <a:latin typeface="Arial"/>
+              </a:defRPr>
+            </a:pPr>
+            <a:r>
+              <a:t>Explainable AI Decision Audit Log</a:t>
+            </a:r>
+          </a:p>
+          <a:p>
+            <a:pPr>
+              <a:spcAft>
+                <a:spcPts val="400"/>
+              </a:spcAft>
+              <a:defRPr sz="1200" b="0">
+                <a:solidFill>
+                  <a:srgbClr val="94A3B8"/>
+                </a:solidFill>
+                <a:latin typeface="Arial"/>
+              </a:defRPr>
+            </a:pPr>
+            <a:r>
+              <a:t>Every single trade is translated into plain-English rationale for C-suite transparency.</a:t>
+            </a:r>
+          </a:p>
+        </p:txBody>
+      </p:sp>
+      <p:pic>
+        <p:nvPicPr>
+          <p:cNvPr id="28" name="Picture 27" descr="image.png"/>
           <p:cNvPicPr>
             <a:picLocks noChangeAspect="1"/>
           </p:cNvPicPr>
@@ -9811,6 +12151,516 @@
           </a:p>
         </p:txBody>
       </p:sp>
+      <p:sp>
+        <p:nvSpPr>
+          <p:cNvPr id="11" name="Rounded Rectangle 10"/>
+          <p:cNvSpPr/>
+          <p:nvPr/>
+        </p:nvSpPr>
+        <p:spPr>
+          <a:xfrm>
+            <a:off x="1463040" y="1920240"/>
+            <a:ext cx="5029200" cy="7680960"/>
+          </a:xfrm>
+          <a:prstGeom prst="roundRect">
+            <a:avLst/>
+          </a:prstGeom>
+          <a:solidFill>
+            <a:srgbClr val="0F172A"/>
+          </a:solidFill>
+          <a:ln w="19050">
+            <a:solidFill>
+              <a:srgbClr val="0EA5E9"/>
+            </a:solidFill>
+          </a:ln>
+        </p:spPr>
+        <p:style>
+          <a:lnRef idx="1">
+            <a:schemeClr val="accent1"/>
+          </a:lnRef>
+          <a:fillRef idx="3">
+            <a:schemeClr val="accent1"/>
+          </a:fillRef>
+          <a:effectRef idx="2">
+            <a:schemeClr val="accent1"/>
+          </a:effectRef>
+          <a:fontRef idx="minor">
+            <a:schemeClr val="lt1"/>
+          </a:fontRef>
+        </p:style>
+        <p:txBody>
+          <a:bodyPr rtlCol="0" anchor="ctr" wrap="square" lIns="228600" rIns="228600" tIns="228600" bIns="228600"/>
+          <a:lstStyle/>
+          <a:p>
+            <a:pPr algn="ctr">
+              <a:spcAft>
+                <a:spcPts val="1000"/>
+              </a:spcAft>
+              <a:defRPr sz="1800" b="1">
+                <a:solidFill>
+                  <a:srgbClr val="38BDF8"/>
+                </a:solidFill>
+                <a:latin typeface="Arial"/>
+              </a:defRPr>
+            </a:pPr>
+            <a:r>
+              <a:t>1. TECHNICAL FEASIBILITY</a:t>
+            </a:r>
+          </a:p>
+          <a:p>
+            <a:pPr>
+              <a:spcAft>
+                <a:spcPts val="1200"/>
+              </a:spcAft>
+              <a:defRPr sz="1400" b="0">
+                <a:solidFill>
+                  <a:srgbClr val="94A3B8"/>
+                </a:solidFill>
+                <a:latin typeface="Arial"/>
+              </a:defRPr>
+            </a:pPr>
+            <a:r>
+              <a:t>Proven benchmarks from our prototype:</a:t>
+            </a:r>
+          </a:p>
+          <a:p>
+            <a:pPr>
+              <a:spcAft>
+                <a:spcPts val="300"/>
+              </a:spcAft>
+              <a:defRPr sz="1500" b="1">
+                <a:solidFill>
+                  <a:srgbClr val="FFFFFF"/>
+                </a:solidFill>
+                <a:latin typeface="Arial"/>
+              </a:defRPr>
+            </a:pPr>
+            <a:r>
+              <a:t>• Lightning-Fast Execution:</a:t>
+            </a:r>
+          </a:p>
+          <a:p>
+            <a:pPr>
+              <a:spcAft>
+                <a:spcPts val="1000"/>
+              </a:spcAft>
+              <a:defRPr sz="1400" b="0">
+                <a:solidFill>
+                  <a:srgbClr val="CBD5E1"/>
+                </a:solidFill>
+                <a:latin typeface="Arial"/>
+              </a:defRPr>
+            </a:pPr>
+            <a:r>
+              <a:t>Optimization converges in 11.4 milliseconds. Risk checks execute in under 2 milliseconds.</a:t>
+            </a:r>
+          </a:p>
+          <a:p>
+            <a:pPr>
+              <a:spcAft>
+                <a:spcPts val="300"/>
+              </a:spcAft>
+              <a:defRPr sz="1500" b="1">
+                <a:solidFill>
+                  <a:srgbClr val="FFFFFF"/>
+                </a:solidFill>
+                <a:latin typeface="Arial"/>
+              </a:defRPr>
+            </a:pPr>
+            <a:r>
+              <a:t>• Zero Cloud / API Fragility:</a:t>
+            </a:r>
+          </a:p>
+          <a:p>
+            <a:pPr>
+              <a:spcAft>
+                <a:spcPts val="1000"/>
+              </a:spcAft>
+              <a:defRPr sz="1400" b="0">
+                <a:solidFill>
+                  <a:srgbClr val="CBD5E1"/>
+                </a:solidFill>
+                <a:latin typeface="Arial"/>
+              </a:defRPr>
+            </a:pPr>
+            <a:r>
+              <a:t>Entire financial engine runs locally without fragile third-party API dependencies. It cannot be taken down by external rate limits.</a:t>
+            </a:r>
+          </a:p>
+          <a:p>
+            <a:pPr>
+              <a:spcAft>
+                <a:spcPts val="300"/>
+              </a:spcAft>
+              <a:defRPr sz="1500" b="1">
+                <a:solidFill>
+                  <a:srgbClr val="FFFFFF"/>
+                </a:solidFill>
+                <a:latin typeface="Arial"/>
+              </a:defRPr>
+            </a:pPr>
+            <a:r>
+              <a:t>• Rigorous Automated Tests:</a:t>
+            </a:r>
+          </a:p>
+          <a:p>
+            <a:pPr>
+              <a:spcAft>
+                <a:spcPts val="0"/>
+              </a:spcAft>
+              <a:defRPr sz="1400" b="0">
+                <a:solidFill>
+                  <a:srgbClr val="CBD5E1"/>
+                </a:solidFill>
+                <a:latin typeface="Arial"/>
+              </a:defRPr>
+            </a:pPr>
+            <a:r>
+              <a:t>40 automated unit &amp; integration tests covering math, drift gating, and circuit breakers execute in just 0.25 seconds with 100% pass rate.</a:t>
+            </a:r>
+          </a:p>
+        </p:txBody>
+      </p:sp>
+      <p:sp>
+        <p:nvSpPr>
+          <p:cNvPr id="12" name="Rounded Rectangle 11"/>
+          <p:cNvSpPr/>
+          <p:nvPr/>
+        </p:nvSpPr>
+        <p:spPr>
+          <a:xfrm>
+            <a:off x="6903720" y="1920240"/>
+            <a:ext cx="5029200" cy="7680960"/>
+          </a:xfrm>
+          <a:prstGeom prst="roundRect">
+            <a:avLst/>
+          </a:prstGeom>
+          <a:solidFill>
+            <a:srgbClr val="0F172A"/>
+          </a:solidFill>
+          <a:ln w="19050">
+            <a:solidFill>
+              <a:srgbClr val="10B981"/>
+            </a:solidFill>
+          </a:ln>
+        </p:spPr>
+        <p:style>
+          <a:lnRef idx="1">
+            <a:schemeClr val="accent1"/>
+          </a:lnRef>
+          <a:fillRef idx="3">
+            <a:schemeClr val="accent1"/>
+          </a:fillRef>
+          <a:effectRef idx="2">
+            <a:schemeClr val="accent1"/>
+          </a:effectRef>
+          <a:fontRef idx="minor">
+            <a:schemeClr val="lt1"/>
+          </a:fontRef>
+        </p:style>
+        <p:txBody>
+          <a:bodyPr rtlCol="0" anchor="ctr" wrap="square" lIns="228600" rIns="228600" tIns="228600" bIns="228600"/>
+          <a:lstStyle/>
+          <a:p>
+            <a:pPr algn="ctr">
+              <a:spcAft>
+                <a:spcPts val="1000"/>
+              </a:spcAft>
+              <a:defRPr sz="1800" b="1">
+                <a:solidFill>
+                  <a:srgbClr val="34D399"/>
+                </a:solidFill>
+                <a:latin typeface="Arial"/>
+              </a:defRPr>
+            </a:pPr>
+            <a:r>
+              <a:t>2. ECONOMIC VIABILITY &amp; ROI</a:t>
+            </a:r>
+          </a:p>
+          <a:p>
+            <a:pPr>
+              <a:spcAft>
+                <a:spcPts val="1200"/>
+              </a:spcAft>
+              <a:defRPr sz="1400" b="0">
+                <a:solidFill>
+                  <a:srgbClr val="94A3B8"/>
+                </a:solidFill>
+                <a:latin typeface="Arial"/>
+              </a:defRPr>
+            </a:pPr>
+            <a:r>
+              <a:t>Measurable cost savings for investors:</a:t>
+            </a:r>
+          </a:p>
+          <a:p>
+            <a:pPr>
+              <a:spcAft>
+                <a:spcPts val="300"/>
+              </a:spcAft>
+              <a:defRPr sz="1500" b="1">
+                <a:solidFill>
+                  <a:srgbClr val="FFFFFF"/>
+                </a:solidFill>
+                <a:latin typeface="Arial"/>
+              </a:defRPr>
+            </a:pPr>
+            <a:r>
+              <a:t>• 60% to 80% Less Trading Fees:</a:t>
+            </a:r>
+          </a:p>
+          <a:p>
+            <a:pPr>
+              <a:spcAft>
+                <a:spcPts val="1000"/>
+              </a:spcAft>
+              <a:defRPr sz="1400" b="0">
+                <a:solidFill>
+                  <a:srgbClr val="CBD5E1"/>
+                </a:solidFill>
+                <a:latin typeface="Arial"/>
+              </a:defRPr>
+            </a:pPr>
+            <a:r>
+              <a:t>By avoiding constant micro-rebalancing, our drift-based execution dramatically reduces transaction penalties and slippage.</a:t>
+            </a:r>
+          </a:p>
+          <a:p>
+            <a:pPr>
+              <a:spcAft>
+                <a:spcPts val="300"/>
+              </a:spcAft>
+              <a:defRPr sz="1500" b="1">
+                <a:solidFill>
+                  <a:srgbClr val="FFFFFF"/>
+                </a:solidFill>
+                <a:latin typeface="Arial"/>
+              </a:defRPr>
+            </a:pPr>
+            <a:r>
+              <a:t>• Millisecond Crash Protection:</a:t>
+            </a:r>
+          </a:p>
+          <a:p>
+            <a:pPr>
+              <a:spcAft>
+                <a:spcPts val="1000"/>
+              </a:spcAft>
+              <a:defRPr sz="1400" b="0">
+                <a:solidFill>
+                  <a:srgbClr val="CBD5E1"/>
+                </a:solidFill>
+                <a:latin typeface="Arial"/>
+              </a:defRPr>
+            </a:pPr>
+            <a:r>
+              <a:t>Replaces 30-minute panic meetings and emotional manual trading with automated, rule-governed capital preservation.</a:t>
+            </a:r>
+          </a:p>
+          <a:p>
+            <a:pPr>
+              <a:spcAft>
+                <a:spcPts val="300"/>
+              </a:spcAft>
+              <a:defRPr sz="1500" b="1">
+                <a:solidFill>
+                  <a:srgbClr val="FFFFFF"/>
+                </a:solidFill>
+                <a:latin typeface="Arial"/>
+              </a:defRPr>
+            </a:pPr>
+            <a:r>
+              <a:t>• Downside Loss Limitation:</a:t>
+            </a:r>
+          </a:p>
+          <a:p>
+            <a:pPr>
+              <a:spcAft>
+                <a:spcPts val="0"/>
+              </a:spcAft>
+              <a:defRPr sz="1400" b="0">
+                <a:solidFill>
+                  <a:srgbClr val="CBD5E1"/>
+                </a:solidFill>
+                <a:latin typeface="Arial"/>
+              </a:defRPr>
+            </a:pPr>
+            <a:r>
+              <a:t>Historically, shielding capital during top 5% worst market days boosts multi-year compound returns by over 30%.</a:t>
+            </a:r>
+          </a:p>
+        </p:txBody>
+      </p:sp>
+      <p:sp>
+        <p:nvSpPr>
+          <p:cNvPr id="13" name="Rounded Rectangle 12"/>
+          <p:cNvSpPr/>
+          <p:nvPr/>
+        </p:nvSpPr>
+        <p:spPr>
+          <a:xfrm>
+            <a:off x="12344400" y="1920240"/>
+            <a:ext cx="5029200" cy="7680960"/>
+          </a:xfrm>
+          <a:prstGeom prst="roundRect">
+            <a:avLst/>
+          </a:prstGeom>
+          <a:solidFill>
+            <a:srgbClr val="0F172A"/>
+          </a:solidFill>
+          <a:ln w="19050">
+            <a:solidFill>
+              <a:srgbClr val="A855F7"/>
+            </a:solidFill>
+          </a:ln>
+        </p:spPr>
+        <p:style>
+          <a:lnRef idx="1">
+            <a:schemeClr val="accent1"/>
+          </a:lnRef>
+          <a:fillRef idx="3">
+            <a:schemeClr val="accent1"/>
+          </a:fillRef>
+          <a:effectRef idx="2">
+            <a:schemeClr val="accent1"/>
+          </a:effectRef>
+          <a:fontRef idx="minor">
+            <a:schemeClr val="lt1"/>
+          </a:fontRef>
+        </p:style>
+        <p:txBody>
+          <a:bodyPr rtlCol="0" anchor="ctr" wrap="square" lIns="228600" rIns="228600" tIns="228600" bIns="228600"/>
+          <a:lstStyle/>
+          <a:p>
+            <a:pPr algn="ctr">
+              <a:spcAft>
+                <a:spcPts val="1000"/>
+              </a:spcAft>
+              <a:defRPr sz="1800" b="1">
+                <a:solidFill>
+                  <a:srgbClr val="D8B4FE"/>
+                </a:solidFill>
+                <a:latin typeface="Arial"/>
+              </a:defRPr>
+            </a:pPr>
+            <a:r>
+              <a:t>3. PRACTICAL REAL-WORLD IMPACT</a:t>
+            </a:r>
+          </a:p>
+          <a:p>
+            <a:pPr>
+              <a:spcAft>
+                <a:spcPts val="1200"/>
+              </a:spcAft>
+              <a:defRPr sz="1400" b="0">
+                <a:solidFill>
+                  <a:srgbClr val="94A3B8"/>
+                </a:solidFill>
+                <a:latin typeface="Arial"/>
+              </a:defRPr>
+            </a:pPr>
+            <a:r>
+              <a:t>Who benefits from FortressFi today:</a:t>
+            </a:r>
+          </a:p>
+          <a:p>
+            <a:pPr>
+              <a:spcAft>
+                <a:spcPts val="300"/>
+              </a:spcAft>
+              <a:defRPr sz="1500" b="1">
+                <a:solidFill>
+                  <a:srgbClr val="FFFFFF"/>
+                </a:solidFill>
+                <a:latin typeface="Arial"/>
+              </a:defRPr>
+            </a:pPr>
+            <a:r>
+              <a:t>• Retail &amp; Student Investors:</a:t>
+            </a:r>
+          </a:p>
+          <a:p>
+            <a:pPr>
+              <a:spcAft>
+                <a:spcPts val="1000"/>
+              </a:spcAft>
+              <a:defRPr sz="1400" b="0">
+                <a:solidFill>
+                  <a:srgbClr val="CBD5E1"/>
+                </a:solidFill>
+                <a:latin typeface="Arial"/>
+              </a:defRPr>
+            </a:pPr>
+            <a:r>
+              <a:t>Gives ordinary people access to institutional-grade risk controls so they can invest without fear of waking up to a wiped-out portfolio.</a:t>
+            </a:r>
+          </a:p>
+          <a:p>
+            <a:pPr>
+              <a:spcAft>
+                <a:spcPts val="300"/>
+              </a:spcAft>
+              <a:defRPr sz="1500" b="1">
+                <a:solidFill>
+                  <a:srgbClr val="FFFFFF"/>
+                </a:solidFill>
+                <a:latin typeface="Arial"/>
+              </a:defRPr>
+            </a:pPr>
+            <a:r>
+              <a:t>• Corporate Treasuries &amp; Family Offices:</a:t>
+            </a:r>
+          </a:p>
+          <a:p>
+            <a:pPr>
+              <a:spcAft>
+                <a:spcPts val="1000"/>
+              </a:spcAft>
+              <a:defRPr sz="1400" b="0">
+                <a:solidFill>
+                  <a:srgbClr val="CBD5E1"/>
+                </a:solidFill>
+                <a:latin typeface="Arial"/>
+              </a:defRPr>
+            </a:pPr>
+            <a:r>
+              <a:t>Companies holding cash reserves can optimize yield while guaranteeing that strict liquidity covenants are never breached.</a:t>
+            </a:r>
+          </a:p>
+          <a:p>
+            <a:pPr>
+              <a:spcAft>
+                <a:spcPts val="300"/>
+              </a:spcAft>
+              <a:defRPr sz="1500" b="1">
+                <a:solidFill>
+                  <a:srgbClr val="FFFFFF"/>
+                </a:solidFill>
+                <a:latin typeface="Arial"/>
+              </a:defRPr>
+            </a:pPr>
+            <a:r>
+              <a:t>• WealthTech &amp; Neo-Brokers:</a:t>
+            </a:r>
+          </a:p>
+          <a:p>
+            <a:pPr>
+              <a:spcAft>
+                <a:spcPts val="0"/>
+              </a:spcAft>
+              <a:defRPr sz="1400" b="0">
+                <a:solidFill>
+                  <a:srgbClr val="CBD5E1"/>
+                </a:solidFill>
+                <a:latin typeface="Arial"/>
+              </a:defRPr>
+            </a:pPr>
+            <a:r>
+              <a:t>A ready-to-integrate API engine that platforms (like Zerodha or Robinhood) can plug in to offer automated 'Safe Cruise' features.</a:t>
+            </a:r>
+          </a:p>
+        </p:txBody>
+      </p:sp>
     </p:spTree>
   </p:cSld>
   <p:clrMapOvr>
@@ -11025,6 +13875,620 @@
             </a:pPr>
             <a:r>
               <a:t>http://localhost:8000</a:t>
+            </a:r>
+            <a:br/>
+            <a:r>
+              <a:t>(Real-time WebSockets &amp; Scenario Lab)</a:t>
+            </a:r>
+          </a:p>
+          <a:p>
+            <a:pPr>
+              <a:spcAft>
+                <a:spcPts val="200"/>
+              </a:spcAft>
+              <a:defRPr sz="1500" b="1">
+                <a:solidFill>
+                  <a:srgbClr val="FFFFFF"/>
+                </a:solidFill>
+                <a:latin typeface="Arial"/>
+              </a:defRPr>
+            </a:pPr>
+            <a:r>
+              <a:t>• Verification Metrics:</a:t>
+            </a:r>
+          </a:p>
+          <a:p>
+            <a:pPr>
+              <a:spcAft>
+                <a:spcPts val="1000"/>
+              </a:spcAft>
+              <a:defRPr sz="1350" b="0">
+                <a:solidFill>
+                  <a:srgbClr val="34D399"/>
+                </a:solidFill>
+                <a:latin typeface="Arial"/>
+              </a:defRPr>
+            </a:pPr>
+            <a:r>
+              <a:t>40 Automated Tests Passing (0.25s)</a:t>
+            </a:r>
+            <a:br/>
+            <a:r>
+              <a:t>Comprehensive Architecture Documentation</a:t>
+            </a:r>
+            <a:br/>
+            <a:r>
+              <a:t>Zero External API Failure Risk</a:t>
+            </a:r>
+          </a:p>
+          <a:p>
+            <a:pPr>
+              <a:spcAft>
+                <a:spcPts val="200"/>
+              </a:spcAft>
+              <a:defRPr sz="1500" b="1">
+                <a:solidFill>
+                  <a:srgbClr val="FFFFFF"/>
+                </a:solidFill>
+                <a:latin typeface="Arial"/>
+              </a:defRPr>
+            </a:pPr>
+            <a:r>
+              <a:t>• Team Contact:</a:t>
+            </a:r>
+          </a:p>
+          <a:p>
+            <a:pPr>
+              <a:spcAft>
+                <a:spcPts val="0"/>
+              </a:spcAft>
+              <a:defRPr sz="1350" b="0">
+                <a:solidFill>
+                  <a:srgbClr val="CBD5E1"/>
+                </a:solidFill>
+                <a:latin typeface="Arial"/>
+              </a:defRPr>
+            </a:pPr>
+            <a:r>
+              <a:t>Built proudly for Init26 FinTech Hackathon</a:t>
+            </a:r>
+          </a:p>
+        </p:txBody>
+      </p:sp>
+      <p:sp>
+        <p:nvSpPr>
+          <p:cNvPr id="11" name="Rounded Rectangle 10"/>
+          <p:cNvSpPr/>
+          <p:nvPr/>
+        </p:nvSpPr>
+        <p:spPr>
+          <a:xfrm>
+            <a:off x="1463040" y="1920240"/>
+            <a:ext cx="5029200" cy="7680960"/>
+          </a:xfrm>
+          <a:prstGeom prst="roundRect">
+            <a:avLst/>
+          </a:prstGeom>
+          <a:solidFill>
+            <a:srgbClr val="0F172A"/>
+          </a:solidFill>
+          <a:ln w="19050">
+            <a:solidFill>
+              <a:srgbClr val="10B981"/>
+            </a:solidFill>
+          </a:ln>
+        </p:spPr>
+        <p:style>
+          <a:lnRef idx="1">
+            <a:schemeClr val="accent1"/>
+          </a:lnRef>
+          <a:fillRef idx="3">
+            <a:schemeClr val="accent1"/>
+          </a:fillRef>
+          <a:effectRef idx="2">
+            <a:schemeClr val="accent1"/>
+          </a:effectRef>
+          <a:fontRef idx="minor">
+            <a:schemeClr val="lt1"/>
+          </a:fontRef>
+        </p:style>
+        <p:txBody>
+          <a:bodyPr rtlCol="0" anchor="ctr" wrap="square" lIns="228600" rIns="228600" tIns="228600" bIns="228600"/>
+          <a:lstStyle/>
+          <a:p>
+            <a:pPr algn="ctr">
+              <a:spcAft>
+                <a:spcPts val="1000"/>
+              </a:spcAft>
+              <a:defRPr sz="1800" b="1">
+                <a:solidFill>
+                  <a:srgbClr val="34D399"/>
+                </a:solidFill>
+                <a:latin typeface="Arial"/>
+              </a:defRPr>
+            </a:pPr>
+            <a:r>
+              <a:t>1. WHY FORTRESSFI WINS</a:t>
+            </a:r>
+          </a:p>
+          <a:p>
+            <a:pPr>
+              <a:spcAft>
+                <a:spcPts val="1200"/>
+              </a:spcAft>
+              <a:defRPr sz="1400" b="0">
+                <a:solidFill>
+                  <a:srgbClr val="94A3B8"/>
+                </a:solidFill>
+                <a:latin typeface="Arial"/>
+              </a:defRPr>
+            </a:pPr>
+            <a:r>
+              <a:t>Clear comparison against alternatives:</a:t>
+            </a:r>
+          </a:p>
+          <a:p>
+            <a:pPr>
+              <a:spcAft>
+                <a:spcPts val="200"/>
+              </a:spcAft>
+              <a:defRPr sz="1500" b="1">
+                <a:solidFill>
+                  <a:srgbClr val="FFFFFF"/>
+                </a:solidFill>
+                <a:latin typeface="Arial"/>
+              </a:defRPr>
+            </a:pPr>
+            <a:r>
+              <a:t>• Traditional Wealth Management:</a:t>
+            </a:r>
+          </a:p>
+          <a:p>
+            <a:pPr>
+              <a:spcAft>
+                <a:spcPts val="800"/>
+              </a:spcAft>
+              <a:defRPr sz="1350" b="0">
+                <a:solidFill>
+                  <a:srgbClr val="F87171"/>
+                </a:solidFill>
+                <a:latin typeface="Arial"/>
+              </a:defRPr>
+            </a:pPr>
+            <a:r>
+              <a:t>[-] Static calendar rebalancing (slow)</a:t>
+            </a:r>
+            <a:br/>
+            <a:r>
+              <a:t>[-] Zero flash crash protection</a:t>
+            </a:r>
+            <a:br/>
+            <a:r>
+              <a:t>[-] Delayed quarterly PDFs</a:t>
+            </a:r>
+          </a:p>
+          <a:p>
+            <a:pPr>
+              <a:spcAft>
+                <a:spcPts val="200"/>
+              </a:spcAft>
+              <a:defRPr sz="1500" b="1">
+                <a:solidFill>
+                  <a:srgbClr val="FFFFFF"/>
+                </a:solidFill>
+                <a:latin typeface="Arial"/>
+              </a:defRPr>
+            </a:pPr>
+            <a:r>
+              <a:t>• Generic Robo-Advisors:</a:t>
+            </a:r>
+          </a:p>
+          <a:p>
+            <a:pPr>
+              <a:spcAft>
+                <a:spcPts val="800"/>
+              </a:spcAft>
+              <a:defRPr sz="1350" b="0">
+                <a:solidFill>
+                  <a:srgbClr val="F87171"/>
+                </a:solidFill>
+                <a:latin typeface="Arial"/>
+              </a:defRPr>
+            </a:pPr>
+            <a:r>
+              <a:t>[-] One-time static risk questionnaires</a:t>
+            </a:r>
+            <a:br/>
+            <a:r>
+              <a:t>[-] High turnover friction fees</a:t>
+            </a:r>
+            <a:br/>
+            <a:r>
+              <a:t>[-] Opaque black-box trades</a:t>
+            </a:r>
+          </a:p>
+          <a:p>
+            <a:pPr>
+              <a:spcAft>
+                <a:spcPts val="200"/>
+              </a:spcAft>
+              <a:defRPr sz="1500" b="1">
+                <a:solidFill>
+                  <a:srgbClr val="FFFFFF"/>
+                </a:solidFill>
+                <a:latin typeface="Arial"/>
+              </a:defRPr>
+            </a:pPr>
+            <a:r>
+              <a:t>• FortressFi (Our Prototype):</a:t>
+            </a:r>
+          </a:p>
+          <a:p>
+            <a:pPr>
+              <a:spcAft>
+                <a:spcPts val="0"/>
+              </a:spcAft>
+              <a:defRPr sz="1350" b="0">
+                <a:solidFill>
+                  <a:srgbClr val="34D399"/>
+                </a:solidFill>
+                <a:latin typeface="Arial"/>
+              </a:defRPr>
+            </a:pPr>
+            <a:r>
+              <a:t>[+] Adaptive drift-gated execution</a:t>
+            </a:r>
+            <a:br/>
+            <a:r>
+              <a:t>[+] 4-tier autonomous de-risking</a:t>
+            </a:r>
+            <a:br/>
+            <a:r>
+              <a:t>[+] Plain-English Decision Audit Log</a:t>
+            </a:r>
+          </a:p>
+        </p:txBody>
+      </p:sp>
+      <p:sp>
+        <p:nvSpPr>
+          <p:cNvPr id="12" name="Rounded Rectangle 11"/>
+          <p:cNvSpPr/>
+          <p:nvPr/>
+        </p:nvSpPr>
+        <p:spPr>
+          <a:xfrm>
+            <a:off x="6903720" y="1920240"/>
+            <a:ext cx="5029200" cy="7680960"/>
+          </a:xfrm>
+          <a:prstGeom prst="roundRect">
+            <a:avLst/>
+          </a:prstGeom>
+          <a:solidFill>
+            <a:srgbClr val="0F172A"/>
+          </a:solidFill>
+          <a:ln w="19050">
+            <a:solidFill>
+              <a:srgbClr val="0EA5E9"/>
+            </a:solidFill>
+          </a:ln>
+        </p:spPr>
+        <p:style>
+          <a:lnRef idx="1">
+            <a:schemeClr val="accent1"/>
+          </a:lnRef>
+          <a:fillRef idx="3">
+            <a:schemeClr val="accent1"/>
+          </a:fillRef>
+          <a:effectRef idx="2">
+            <a:schemeClr val="accent1"/>
+          </a:effectRef>
+          <a:fontRef idx="minor">
+            <a:schemeClr val="lt1"/>
+          </a:fontRef>
+        </p:style>
+        <p:txBody>
+          <a:bodyPr rtlCol="0" anchor="ctr" wrap="square" lIns="228600" rIns="228600" tIns="228600" bIns="228600"/>
+          <a:lstStyle/>
+          <a:p>
+            <a:pPr algn="ctr">
+              <a:spcAft>
+                <a:spcPts val="1000"/>
+              </a:spcAft>
+              <a:defRPr sz="1800" b="1">
+                <a:solidFill>
+                  <a:srgbClr val="38BDF8"/>
+                </a:solidFill>
+                <a:latin typeface="Arial"/>
+              </a:defRPr>
+            </a:pPr>
+            <a:r>
+              <a:t>2. FINANCIAL &amp; SCIENTIFIC BACKING</a:t>
+            </a:r>
+          </a:p>
+          <a:p>
+            <a:pPr>
+              <a:spcAft>
+                <a:spcPts val="1200"/>
+              </a:spcAft>
+              <a:defRPr sz="1400" b="0">
+                <a:solidFill>
+                  <a:srgbClr val="94A3B8"/>
+                </a:solidFill>
+                <a:latin typeface="Arial"/>
+              </a:defRPr>
+            </a:pPr>
+            <a:r>
+              <a:t>Built on proven financial engineering:</a:t>
+            </a:r>
+          </a:p>
+          <a:p>
+            <a:pPr>
+              <a:spcAft>
+                <a:spcPts val="200"/>
+              </a:spcAft>
+              <a:defRPr sz="1500" b="1">
+                <a:solidFill>
+                  <a:srgbClr val="FFFFFF"/>
+                </a:solidFill>
+                <a:latin typeface="Arial"/>
+              </a:defRPr>
+            </a:pPr>
+            <a:r>
+              <a:t>1. Markowitz, Harry (1952)</a:t>
+            </a:r>
+          </a:p>
+          <a:p>
+            <a:pPr>
+              <a:spcAft>
+                <a:spcPts val="800"/>
+              </a:spcAft>
+              <a:defRPr sz="1350" b="0">
+                <a:solidFill>
+                  <a:srgbClr val="CBD5E1"/>
+                </a:solidFill>
+                <a:latin typeface="Arial"/>
+              </a:defRPr>
+            </a:pPr>
+            <a:r>
+              <a:t>'Portfolio Selection', Journal of Finance.</a:t>
+            </a:r>
+            <a:br/>
+            <a:r>
+              <a:t>(Foundation of Mean-Variance optimization).</a:t>
+            </a:r>
+          </a:p>
+          <a:p>
+            <a:pPr>
+              <a:spcAft>
+                <a:spcPts val="200"/>
+              </a:spcAft>
+              <a:defRPr sz="1500" b="1">
+                <a:solidFill>
+                  <a:srgbClr val="FFFFFF"/>
+                </a:solidFill>
+                <a:latin typeface="Arial"/>
+              </a:defRPr>
+            </a:pPr>
+            <a:r>
+              <a:t>2. Rockafellar &amp; Uryasev (2000)</a:t>
+            </a:r>
+          </a:p>
+          <a:p>
+            <a:pPr>
+              <a:spcAft>
+                <a:spcPts val="800"/>
+              </a:spcAft>
+              <a:defRPr sz="1350" b="0">
+                <a:solidFill>
+                  <a:srgbClr val="CBD5E1"/>
+                </a:solidFill>
+                <a:latin typeface="Arial"/>
+              </a:defRPr>
+            </a:pPr>
+            <a:r>
+              <a:t>'Optimization of Conditional Value-at-Risk', Journal of Risk. (Tail risk management).</a:t>
+            </a:r>
+          </a:p>
+          <a:p>
+            <a:pPr>
+              <a:spcAft>
+                <a:spcPts val="200"/>
+              </a:spcAft>
+              <a:defRPr sz="1500" b="1">
+                <a:solidFill>
+                  <a:srgbClr val="FFFFFF"/>
+                </a:solidFill>
+                <a:latin typeface="Arial"/>
+              </a:defRPr>
+            </a:pPr>
+            <a:r>
+              <a:t>3. Basel Committee (FRTB - 2019)</a:t>
+            </a:r>
+          </a:p>
+          <a:p>
+            <a:pPr>
+              <a:spcAft>
+                <a:spcPts val="800"/>
+              </a:spcAft>
+              <a:defRPr sz="1350" b="0">
+                <a:solidFill>
+                  <a:srgbClr val="CBD5E1"/>
+                </a:solidFill>
+                <a:latin typeface="Arial"/>
+              </a:defRPr>
+            </a:pPr>
+            <a:r>
+              <a:t>Global banking standards mandating Expected Shortfall / CVaR for market risk.</a:t>
+            </a:r>
+          </a:p>
+          <a:p>
+            <a:pPr>
+              <a:spcAft>
+                <a:spcPts val="200"/>
+              </a:spcAft>
+              <a:defRPr sz="1500" b="1">
+                <a:solidFill>
+                  <a:srgbClr val="FFFFFF"/>
+                </a:solidFill>
+                <a:latin typeface="Arial"/>
+              </a:defRPr>
+            </a:pPr>
+            <a:r>
+              <a:t>4. Dieter Kraft (1988)</a:t>
+            </a:r>
+          </a:p>
+          <a:p>
+            <a:pPr>
+              <a:spcAft>
+                <a:spcPts val="0"/>
+              </a:spcAft>
+              <a:defRPr sz="1350" b="0">
+                <a:solidFill>
+                  <a:srgbClr val="CBD5E1"/>
+                </a:solidFill>
+                <a:latin typeface="Arial"/>
+              </a:defRPr>
+            </a:pPr>
+            <a:r>
+              <a:t>Sequential Least Squares Quadratic Programming (SLSQP).</a:t>
+            </a:r>
+          </a:p>
+        </p:txBody>
+      </p:sp>
+      <p:sp>
+        <p:nvSpPr>
+          <p:cNvPr id="13" name="Rounded Rectangle 12"/>
+          <p:cNvSpPr/>
+          <p:nvPr/>
+        </p:nvSpPr>
+        <p:spPr>
+          <a:xfrm>
+            <a:off x="12344400" y="1920240"/>
+            <a:ext cx="5029200" cy="7680960"/>
+          </a:xfrm>
+          <a:prstGeom prst="roundRect">
+            <a:avLst/>
+          </a:prstGeom>
+          <a:solidFill>
+            <a:srgbClr val="0F172A"/>
+          </a:solidFill>
+          <a:ln w="19050">
+            <a:solidFill>
+              <a:srgbClr val="A855F7"/>
+            </a:solidFill>
+          </a:ln>
+        </p:spPr>
+        <p:style>
+          <a:lnRef idx="1">
+            <a:schemeClr val="accent1"/>
+          </a:lnRef>
+          <a:fillRef idx="3">
+            <a:schemeClr val="accent1"/>
+          </a:fillRef>
+          <a:effectRef idx="2">
+            <a:schemeClr val="accent1"/>
+          </a:effectRef>
+          <a:fontRef idx="minor">
+            <a:schemeClr val="lt1"/>
+          </a:fontRef>
+        </p:style>
+        <p:txBody>
+          <a:bodyPr rtlCol="0" anchor="ctr" wrap="square" lIns="228600" rIns="228600" tIns="228600" bIns="228600"/>
+          <a:lstStyle/>
+          <a:p>
+            <a:pPr algn="ctr">
+              <a:spcAft>
+                <a:spcPts val="1000"/>
+              </a:spcAft>
+              <a:defRPr sz="1800" b="1">
+                <a:solidFill>
+                  <a:srgbClr val="D8B4FE"/>
+                </a:solidFill>
+                <a:latin typeface="Arial"/>
+              </a:defRPr>
+            </a:pPr>
+            <a:r>
+              <a:t>3. OPEN-SOURCE CODE &amp; DELIVERABLES</a:t>
+            </a:r>
+          </a:p>
+          <a:p>
+            <a:pPr>
+              <a:spcAft>
+                <a:spcPts val="1200"/>
+              </a:spcAft>
+              <a:defRPr sz="1400" b="0">
+                <a:solidFill>
+                  <a:srgbClr val="94A3B8"/>
+                </a:solidFill>
+                <a:latin typeface="Arial"/>
+              </a:defRPr>
+            </a:pPr>
+            <a:r>
+              <a:t>Everything is built, verified, and public:</a:t>
+            </a:r>
+          </a:p>
+          <a:p>
+            <a:pPr>
+              <a:spcAft>
+                <a:spcPts val="200"/>
+              </a:spcAft>
+              <a:defRPr sz="1500" b="1">
+                <a:solidFill>
+                  <a:srgbClr val="FFFFFF"/>
+                </a:solidFill>
+                <a:latin typeface="Arial"/>
+              </a:defRPr>
+            </a:pPr>
+            <a:r>
+              <a:t>• GitHub Repository:</a:t>
+            </a:r>
+          </a:p>
+          <a:p>
+            <a:pPr>
+              <a:spcAft>
+                <a:spcPts val="1000"/>
+              </a:spcAft>
+              <a:defRPr sz="1350" b="1">
+                <a:solidFill>
+                  <a:srgbClr val="38BDF8"/>
+                </a:solidFill>
+                <a:latin typeface="Arial"/>
+              </a:defRPr>
+            </a:pPr>
+            <a:r>
+              <a:t>https://github.com/tarun05-design/FortressFi.git</a:t>
+            </a:r>
+          </a:p>
+          <a:p>
+            <a:pPr>
+              <a:spcAft>
+                <a:spcPts val="200"/>
+              </a:spcAft>
+              <a:defRPr sz="1500" b="1">
+                <a:solidFill>
+                  <a:srgbClr val="FFFFFF"/>
+                </a:solidFill>
+                <a:latin typeface="Arial"/>
+              </a:defRPr>
+            </a:pPr>
+            <a:r>
+              <a:t>• Live Interactive Cockpit:</a:t>
+            </a:r>
+          </a:p>
+          <a:p>
+            <a:pPr>
+              <a:spcAft>
+                <a:spcPts val="1000"/>
+              </a:spcAft>
+              <a:defRPr sz="1350" b="1">
+                <a:solidFill>
+                  <a:srgbClr val="34D399"/>
+                </a:solidFill>
+                <a:latin typeface="Arial"/>
+              </a:defRPr>
+            </a:pPr>
+            <a:r>
+              <a:t>https://fortressfi.onrender.com</a:t>
             </a:r>
             <a:br/>
             <a:r>

</xml_diff>